<commit_message>
Montador v5: cajas stats 10×3cm, descripción 13pt, headline 50pt fijo
Feedback Jeremy 14-may-2026 (Pilar Mujer):
- Cajas de stats medidas en CENTÍMETROS (no pulgadas): 10cm × 3cm = 378 × 113 px @ 96dpi
- Descripción de stats: 13pt fijo (antes 16pt)
- Headline del hallazgo: 50pt fijo (ya estaba, reforzado)
- Layouts 1, 2, 3 recalculados con nuevos gaps (1stat centered, 2stats gap 200pt, 3stats gap 100pt)
- aprendizajes-montador-cc.md actualizado para próximas routines (Opiniones Políticas hereda esto)
- mujer-deck-flat.pptx re-generado con las nuevas dimensiones
</commit_message>
<xml_diff>
--- a/Agentes Hallazgos/mujer-deck-flat.pptx
+++ b/Agentes Hallazgos/mujer-deck-flat.pptx
@@ -3145,7 +3145,7 @@
           <a:p>
             <a:pPr algn="ctr"/>
             <a:r>
-              <a:rPr sz="3150" b="0" i="0" kern="0" spc="0">
+              <a:rPr sz="5000" b="0" i="0" kern="0" spc="0">
                 <a:solidFill>
                   <a:srgbClr val="FFFFFF"/>
                 </a:solidFill>
@@ -3154,7 +3154,7 @@
               <a:t>LA MUJER DE 35-44 AÑOS VIVE EN LA FAMILIA NUCLEAR. LA MUJER DE ESTRATO E Y LA DE 55+ </a:t>
             </a:r>
             <a:r>
-              <a:rPr sz="3150" b="0" i="1" kern="0" spc="0">
+              <a:rPr sz="5000" b="0" i="1" kern="0" spc="0">
                 <a:solidFill>
                   <a:srgbClr val="FFFFFF"/>
                 </a:solidFill>
@@ -3174,7 +3174,7 @@
         <p:spPr>
           <a:xfrm>
             <a:off x="6848475" y="4572000"/>
-            <a:ext cx="19050" cy="2647950"/>
+            <a:ext cx="19050" cy="1457325"/>
           </a:xfrm>
           <a:prstGeom prst="rect">
             <a:avLst/>
@@ -3217,7 +3217,7 @@
         <p:spPr>
           <a:xfrm>
             <a:off x="11420475" y="4572000"/>
-            <a:ext cx="19050" cy="2647950"/>
+            <a:ext cx="19050" cy="1457325"/>
           </a:xfrm>
           <a:prstGeom prst="rect">
             <a:avLst/>
@@ -3259,8 +3259,8 @@
         </p:nvSpPr>
         <p:spPr>
           <a:xfrm>
-            <a:off x="1905000" y="4762500"/>
-            <a:ext cx="5334000" cy="1905000"/>
+            <a:off x="2771775" y="4762500"/>
+            <a:ext cx="3600450" cy="1905000"/>
           </a:xfrm>
           <a:prstGeom prst="rect">
             <a:avLst/>
@@ -3294,23 +3294,23 @@
         </p:nvSpPr>
         <p:spPr>
           <a:xfrm>
-            <a:off x="1905000" y="6858000"/>
-            <a:ext cx="5334000" cy="1714500"/>
-          </a:xfrm>
-          <a:prstGeom prst="rect">
-            <a:avLst/>
-          </a:prstGeom>
-          <a:noFill/>
-        </p:spPr>
-        <p:txBody>
-          <a:bodyPr wrap="square" lIns="0" rIns="0" tIns="0" bIns="0">
-            <a:spAutoFit/>
-          </a:bodyPr>
-          <a:lstStyle/>
-          <a:p>
-            <a:pPr algn="ctr"/>
-            <a:r>
-              <a:rPr sz="1650" b="0" i="0" kern="0" spc="0">
+            <a:off x="2771775" y="6858000"/>
+            <a:ext cx="3600450" cy="1076325"/>
+          </a:xfrm>
+          <a:prstGeom prst="rect">
+            <a:avLst/>
+          </a:prstGeom>
+          <a:noFill/>
+        </p:spPr>
+        <p:txBody>
+          <a:bodyPr wrap="square" lIns="0" rIns="0" tIns="0" bIns="0">
+            <a:spAutoFit/>
+          </a:bodyPr>
+          <a:lstStyle/>
+          <a:p>
+            <a:pPr algn="ctr"/>
+            <a:r>
+              <a:rPr sz="1300" b="0" i="0" kern="0" spc="0">
                 <a:solidFill>
                   <a:srgbClr val="FFFFFF"/>
                 </a:solidFill>
@@ -3319,7 +3319,7 @@
               <a:t>de las mujeres de </a:t>
             </a:r>
             <a:r>
-              <a:rPr sz="1650" b="1" i="0" kern="0" spc="0">
+              <a:rPr sz="1300" b="1" i="0" kern="0" spc="0">
                 <a:solidFill>
                   <a:srgbClr val="FFFFFF"/>
                 </a:solidFill>
@@ -3328,7 +3328,7 @@
               <a:t>35-44 años</a:t>
             </a:r>
             <a:r>
-              <a:rPr sz="1650" b="0" i="0" kern="0" spc="0">
+              <a:rPr sz="1300" b="0" i="0" kern="0" spc="0">
                 <a:solidFill>
                   <a:srgbClr val="FFFFFF"/>
                 </a:solidFill>
@@ -3347,8 +3347,8 @@
         </p:nvSpPr>
         <p:spPr>
           <a:xfrm>
-            <a:off x="6477000" y="4762500"/>
-            <a:ext cx="5334000" cy="1905000"/>
+            <a:off x="7343775" y="4762500"/>
+            <a:ext cx="3600450" cy="1905000"/>
           </a:xfrm>
           <a:prstGeom prst="rect">
             <a:avLst/>
@@ -3382,23 +3382,23 @@
         </p:nvSpPr>
         <p:spPr>
           <a:xfrm>
-            <a:off x="6477000" y="6858000"/>
-            <a:ext cx="5334000" cy="1714500"/>
-          </a:xfrm>
-          <a:prstGeom prst="rect">
-            <a:avLst/>
-          </a:prstGeom>
-          <a:noFill/>
-        </p:spPr>
-        <p:txBody>
-          <a:bodyPr wrap="square" lIns="0" rIns="0" tIns="0" bIns="0">
-            <a:spAutoFit/>
-          </a:bodyPr>
-          <a:lstStyle/>
-          <a:p>
-            <a:pPr algn="ctr"/>
-            <a:r>
-              <a:rPr sz="1650" b="0" i="0" kern="0" spc="0">
+            <a:off x="7343775" y="6858000"/>
+            <a:ext cx="3600450" cy="1076325"/>
+          </a:xfrm>
+          <a:prstGeom prst="rect">
+            <a:avLst/>
+          </a:prstGeom>
+          <a:noFill/>
+        </p:spPr>
+        <p:txBody>
+          <a:bodyPr wrap="square" lIns="0" rIns="0" tIns="0" bIns="0">
+            <a:spAutoFit/>
+          </a:bodyPr>
+          <a:lstStyle/>
+          <a:p>
+            <a:pPr algn="ctr"/>
+            <a:r>
+              <a:rPr sz="1300" b="0" i="0" kern="0" spc="0">
                 <a:solidFill>
                   <a:srgbClr val="FFFFFF"/>
                 </a:solidFill>
@@ -3407,7 +3407,7 @@
               <a:t>de las mujeres del </a:t>
             </a:r>
             <a:r>
-              <a:rPr sz="1650" b="1" i="0" kern="0" spc="0">
+              <a:rPr sz="1300" b="1" i="0" kern="0" spc="0">
                 <a:solidFill>
                   <a:srgbClr val="FFFFFF"/>
                 </a:solidFill>
@@ -3416,7 +3416,7 @@
               <a:t>estrato E</a:t>
             </a:r>
             <a:r>
-              <a:rPr sz="1650" b="0" i="0" kern="0" spc="0">
+              <a:rPr sz="1300" b="0" i="0" kern="0" spc="0">
                 <a:solidFill>
                   <a:srgbClr val="FFFFFF"/>
                 </a:solidFill>
@@ -3435,8 +3435,8 @@
         </p:nvSpPr>
         <p:spPr>
           <a:xfrm>
-            <a:off x="11049000" y="4762500"/>
-            <a:ext cx="5334000" cy="1905000"/>
+            <a:off x="11915775" y="4762500"/>
+            <a:ext cx="3600450" cy="1905000"/>
           </a:xfrm>
           <a:prstGeom prst="rect">
             <a:avLst/>
@@ -3470,23 +3470,23 @@
         </p:nvSpPr>
         <p:spPr>
           <a:xfrm>
-            <a:off x="11049000" y="6858000"/>
-            <a:ext cx="5334000" cy="1714500"/>
-          </a:xfrm>
-          <a:prstGeom prst="rect">
-            <a:avLst/>
-          </a:prstGeom>
-          <a:noFill/>
-        </p:spPr>
-        <p:txBody>
-          <a:bodyPr wrap="square" lIns="0" rIns="0" tIns="0" bIns="0">
-            <a:spAutoFit/>
-          </a:bodyPr>
-          <a:lstStyle/>
-          <a:p>
-            <a:pPr algn="ctr"/>
-            <a:r>
-              <a:rPr sz="1650" b="0" i="0" kern="0" spc="0">
+            <a:off x="11915775" y="6858000"/>
+            <a:ext cx="3600450" cy="1076325"/>
+          </a:xfrm>
+          <a:prstGeom prst="rect">
+            <a:avLst/>
+          </a:prstGeom>
+          <a:noFill/>
+        </p:spPr>
+        <p:txBody>
+          <a:bodyPr wrap="square" lIns="0" rIns="0" tIns="0" bIns="0">
+            <a:spAutoFit/>
+          </a:bodyPr>
+          <a:lstStyle/>
+          <a:p>
+            <a:pPr algn="ctr"/>
+            <a:r>
+              <a:rPr sz="1300" b="0" i="0" kern="0" spc="0">
                 <a:solidFill>
                   <a:srgbClr val="FFFFFF"/>
                 </a:solidFill>
@@ -3495,7 +3495,7 @@
               <a:t>de las mujeres de </a:t>
             </a:r>
             <a:r>
-              <a:rPr sz="1650" b="1" i="0" kern="0" spc="0">
+              <a:rPr sz="1300" b="1" i="0" kern="0" spc="0">
                 <a:solidFill>
                   <a:srgbClr val="FFFFFF"/>
                 </a:solidFill>
@@ -3504,7 +3504,7 @@
               <a:t>55+</a:t>
             </a:r>
             <a:r>
-              <a:rPr sz="1650" b="0" i="0" kern="0" spc="0">
+              <a:rPr sz="1300" b="0" i="0" kern="0" spc="0">
                 <a:solidFill>
                   <a:srgbClr val="FFFFFF"/>
                 </a:solidFill>
@@ -3759,7 +3759,7 @@
           <a:p>
             <a:pPr algn="ctr"/>
             <a:r>
-              <a:rPr sz="3150" b="0" i="0" kern="0" spc="0">
+              <a:rPr sz="5000" b="0" i="0" kern="0" spc="0">
                 <a:solidFill>
                   <a:srgbClr val="FFFFFF"/>
                 </a:solidFill>
@@ -3768,7 +3768,7 @@
               <a:t>COCINA: 66.6% DE ELLA. LIMPIEZA: 59.6% DE ELLA. MANEJO DEL DINERO DEL HOGAR: </a:t>
             </a:r>
             <a:r>
-              <a:rPr sz="3150" b="0" i="1" kern="0" spc="0">
+              <a:rPr sz="5000" b="0" i="1" kern="0" spc="0">
                 <a:solidFill>
                   <a:srgbClr val="FFFFFF"/>
                 </a:solidFill>
@@ -3788,7 +3788,7 @@
         <p:spPr>
           <a:xfrm>
             <a:off x="6848475" y="4572000"/>
-            <a:ext cx="19050" cy="2647950"/>
+            <a:ext cx="19050" cy="1457325"/>
           </a:xfrm>
           <a:prstGeom prst="rect">
             <a:avLst/>
@@ -3831,7 +3831,7 @@
         <p:spPr>
           <a:xfrm>
             <a:off x="11420475" y="4572000"/>
-            <a:ext cx="19050" cy="2647950"/>
+            <a:ext cx="19050" cy="1457325"/>
           </a:xfrm>
           <a:prstGeom prst="rect">
             <a:avLst/>
@@ -3873,8 +3873,8 @@
         </p:nvSpPr>
         <p:spPr>
           <a:xfrm>
-            <a:off x="1905000" y="4762500"/>
-            <a:ext cx="5334000" cy="1905000"/>
+            <a:off x="2771775" y="4762500"/>
+            <a:ext cx="3600450" cy="1905000"/>
           </a:xfrm>
           <a:prstGeom prst="rect">
             <a:avLst/>
@@ -3908,23 +3908,23 @@
         </p:nvSpPr>
         <p:spPr>
           <a:xfrm>
-            <a:off x="1905000" y="6858000"/>
-            <a:ext cx="5334000" cy="1714500"/>
-          </a:xfrm>
-          <a:prstGeom prst="rect">
-            <a:avLst/>
-          </a:prstGeom>
-          <a:noFill/>
-        </p:spPr>
-        <p:txBody>
-          <a:bodyPr wrap="square" lIns="0" rIns="0" tIns="0" bIns="0">
-            <a:spAutoFit/>
-          </a:bodyPr>
-          <a:lstStyle/>
-          <a:p>
-            <a:pPr algn="ctr"/>
-            <a:r>
-              <a:rPr sz="1650" b="0" i="0" kern="0" spc="0">
+            <a:off x="2771775" y="6858000"/>
+            <a:ext cx="3600450" cy="1076325"/>
+          </a:xfrm>
+          <a:prstGeom prst="rect">
+            <a:avLst/>
+          </a:prstGeom>
+          <a:noFill/>
+        </p:spPr>
+        <p:txBody>
+          <a:bodyPr wrap="square" lIns="0" rIns="0" tIns="0" bIns="0">
+            <a:spAutoFit/>
+          </a:bodyPr>
+          <a:lstStyle/>
+          <a:p>
+            <a:pPr algn="ctr"/>
+            <a:r>
+              <a:rPr sz="1300" b="0" i="0" kern="0" spc="0">
                 <a:solidFill>
                   <a:srgbClr val="FFFFFF"/>
                 </a:solidFill>
@@ -3933,7 +3933,7 @@
               <a:t>dice que el </a:t>
             </a:r>
             <a:r>
-              <a:rPr sz="1650" b="1" i="0" kern="0" spc="0">
+              <a:rPr sz="1300" b="1" i="0" kern="0" spc="0">
                 <a:solidFill>
                   <a:srgbClr val="FFFFFF"/>
                 </a:solidFill>
@@ -3942,7 +3942,7 @@
               <a:t>pago de servicios</a:t>
             </a:r>
             <a:r>
-              <a:rPr sz="1650" b="0" i="0" kern="0" spc="0">
+              <a:rPr sz="1300" b="0" i="0" kern="0" spc="0">
                 <a:solidFill>
                   <a:srgbClr val="FFFFFF"/>
                 </a:solidFill>
@@ -3961,8 +3961,8 @@
         </p:nvSpPr>
         <p:spPr>
           <a:xfrm>
-            <a:off x="6477000" y="4762500"/>
-            <a:ext cx="5334000" cy="1905000"/>
+            <a:off x="7343775" y="4762500"/>
+            <a:ext cx="3600450" cy="1905000"/>
           </a:xfrm>
           <a:prstGeom prst="rect">
             <a:avLst/>
@@ -3996,23 +3996,23 @@
         </p:nvSpPr>
         <p:spPr>
           <a:xfrm>
-            <a:off x="6477000" y="6858000"/>
-            <a:ext cx="5334000" cy="1714500"/>
-          </a:xfrm>
-          <a:prstGeom prst="rect">
-            <a:avLst/>
-          </a:prstGeom>
-          <a:noFill/>
-        </p:spPr>
-        <p:txBody>
-          <a:bodyPr wrap="square" lIns="0" rIns="0" tIns="0" bIns="0">
-            <a:spAutoFit/>
-          </a:bodyPr>
-          <a:lstStyle/>
-          <a:p>
-            <a:pPr algn="ctr"/>
-            <a:r>
-              <a:rPr sz="1650" b="0" i="0" kern="0" spc="0">
+            <a:off x="7343775" y="6858000"/>
+            <a:ext cx="3600450" cy="1076325"/>
+          </a:xfrm>
+          <a:prstGeom prst="rect">
+            <a:avLst/>
+          </a:prstGeom>
+          <a:noFill/>
+        </p:spPr>
+        <p:txBody>
+          <a:bodyPr wrap="square" lIns="0" rIns="0" tIns="0" bIns="0">
+            <a:spAutoFit/>
+          </a:bodyPr>
+          <a:lstStyle/>
+          <a:p>
+            <a:pPr algn="ctr"/>
+            <a:r>
+              <a:rPr sz="1300" b="0" i="0" kern="0" spc="0">
                 <a:solidFill>
                   <a:srgbClr val="FFFFFF"/>
                 </a:solidFill>
@@ -4021,7 +4021,7 @@
               <a:t>dice que el </a:t>
             </a:r>
             <a:r>
-              <a:rPr sz="1650" b="1" i="0" kern="0" spc="0">
+              <a:rPr sz="1300" b="1" i="0" kern="0" spc="0">
                 <a:solidFill>
                   <a:srgbClr val="FFFFFF"/>
                 </a:solidFill>
@@ -4030,7 +4030,7 @@
               <a:t>manejo del dinero del hogar</a:t>
             </a:r>
             <a:r>
-              <a:rPr sz="1650" b="0" i="0" kern="0" spc="0">
+              <a:rPr sz="1300" b="0" i="0" kern="0" spc="0">
                 <a:solidFill>
                   <a:srgbClr val="FFFFFF"/>
                 </a:solidFill>
@@ -4049,8 +4049,8 @@
         </p:nvSpPr>
         <p:spPr>
           <a:xfrm>
-            <a:off x="11049000" y="4762500"/>
-            <a:ext cx="5334000" cy="1905000"/>
+            <a:off x="11915775" y="4762500"/>
+            <a:ext cx="3600450" cy="1905000"/>
           </a:xfrm>
           <a:prstGeom prst="rect">
             <a:avLst/>
@@ -4084,23 +4084,23 @@
         </p:nvSpPr>
         <p:spPr>
           <a:xfrm>
-            <a:off x="11049000" y="6858000"/>
-            <a:ext cx="5334000" cy="1714500"/>
-          </a:xfrm>
-          <a:prstGeom prst="rect">
-            <a:avLst/>
-          </a:prstGeom>
-          <a:noFill/>
-        </p:spPr>
-        <p:txBody>
-          <a:bodyPr wrap="square" lIns="0" rIns="0" tIns="0" bIns="0">
-            <a:spAutoFit/>
-          </a:bodyPr>
-          <a:lstStyle/>
-          <a:p>
-            <a:pPr algn="ctr"/>
-            <a:r>
-              <a:rPr sz="1650" b="0" i="0" kern="0" spc="0">
+            <a:off x="11915775" y="6858000"/>
+            <a:ext cx="3600450" cy="1076325"/>
+          </a:xfrm>
+          <a:prstGeom prst="rect">
+            <a:avLst/>
+          </a:prstGeom>
+          <a:noFill/>
+        </p:spPr>
+        <p:txBody>
+          <a:bodyPr wrap="square" lIns="0" rIns="0" tIns="0" bIns="0">
+            <a:spAutoFit/>
+          </a:bodyPr>
+          <a:lstStyle/>
+          <a:p>
+            <a:pPr algn="ctr"/>
+            <a:r>
+              <a:rPr sz="1300" b="0" i="0" kern="0" spc="0">
                 <a:solidFill>
                   <a:srgbClr val="FFFFFF"/>
                 </a:solidFill>
@@ -4109,7 +4109,7 @@
               <a:t>declara “</a:t>
             </a:r>
             <a:r>
-              <a:rPr sz="1650" b="1" i="0" kern="0" spc="0">
+              <a:rPr sz="1300" b="1" i="0" kern="0" spc="0">
                 <a:solidFill>
                   <a:srgbClr val="FFFFFF"/>
                 </a:solidFill>
@@ -4118,7 +4118,7 @@
               <a:t>ambos por igual</a:t>
             </a:r>
             <a:r>
-              <a:rPr sz="1650" b="0" i="0" kern="0" spc="0">
+              <a:rPr sz="1300" b="0" i="0" kern="0" spc="0">
                 <a:solidFill>
                   <a:srgbClr val="FFFFFF"/>
                 </a:solidFill>
@@ -4214,7 +4214,7 @@
           <a:p>
             <a:pPr algn="ctr"/>
             <a:r>
-              <a:rPr sz="3150" b="0" i="0" kern="0" spc="0">
+              <a:rPr sz="5000" b="0" i="0" kern="0" spc="0">
                 <a:solidFill>
                   <a:srgbClr val="FFFFFF"/>
                 </a:solidFill>
@@ -4223,7 +4223,7 @@
               <a:t>45.2% DICE QUE ACOMPAÑAR A CITAS MÉDICAS O ESCOLARES LO HACE ELLA. </a:t>
             </a:r>
             <a:r>
-              <a:rPr sz="3150" b="0" i="1" kern="0" spc="0">
+              <a:rPr sz="5000" b="0" i="1" kern="0" spc="0">
                 <a:solidFill>
                   <a:srgbClr val="FFFFFF"/>
                 </a:solidFill>
@@ -4243,7 +4243,7 @@
         <p:spPr>
           <a:xfrm>
             <a:off x="9134475" y="4572000"/>
-            <a:ext cx="19050" cy="2647950"/>
+            <a:ext cx="19050" cy="1457325"/>
           </a:xfrm>
           <a:prstGeom prst="rect">
             <a:avLst/>
@@ -4285,8 +4285,8 @@
         </p:nvSpPr>
         <p:spPr>
           <a:xfrm>
-            <a:off x="1905000" y="4762500"/>
-            <a:ext cx="8382000" cy="1905000"/>
+            <a:off x="4295775" y="4762500"/>
+            <a:ext cx="3600450" cy="1905000"/>
           </a:xfrm>
           <a:prstGeom prst="rect">
             <a:avLst/>
@@ -4320,23 +4320,23 @@
         </p:nvSpPr>
         <p:spPr>
           <a:xfrm>
-            <a:off x="1905000" y="6858000"/>
-            <a:ext cx="8382000" cy="1714500"/>
-          </a:xfrm>
-          <a:prstGeom prst="rect">
-            <a:avLst/>
-          </a:prstGeom>
-          <a:noFill/>
-        </p:spPr>
-        <p:txBody>
-          <a:bodyPr wrap="square" lIns="0" rIns="0" tIns="0" bIns="0">
-            <a:spAutoFit/>
-          </a:bodyPr>
-          <a:lstStyle/>
-          <a:p>
-            <a:pPr algn="ctr"/>
-            <a:r>
-              <a:rPr sz="1650" b="0" i="0" kern="0" spc="0">
+            <a:off x="4295775" y="6858000"/>
+            <a:ext cx="3600450" cy="1076325"/>
+          </a:xfrm>
+          <a:prstGeom prst="rect">
+            <a:avLst/>
+          </a:prstGeom>
+          <a:noFill/>
+        </p:spPr>
+        <p:txBody>
+          <a:bodyPr wrap="square" lIns="0" rIns="0" tIns="0" bIns="0">
+            <a:spAutoFit/>
+          </a:bodyPr>
+          <a:lstStyle/>
+          <a:p>
+            <a:pPr algn="ctr"/>
+            <a:r>
+              <a:rPr sz="1300" b="0" i="0" kern="0" spc="0">
                 <a:solidFill>
                   <a:srgbClr val="FFFFFF"/>
                 </a:solidFill>
@@ -4345,7 +4345,7 @@
               <a:t>del subsample femenino dice que </a:t>
             </a:r>
             <a:r>
-              <a:rPr sz="1650" b="1" i="0" kern="0" spc="0">
+              <a:rPr sz="1300" b="1" i="0" kern="0" spc="0">
                 <a:solidFill>
                   <a:srgbClr val="FFFFFF"/>
                 </a:solidFill>
@@ -4354,7 +4354,7 @@
               <a:t>citas médicas o escolares</a:t>
             </a:r>
             <a:r>
-              <a:rPr sz="1650" b="0" i="0" kern="0" spc="0">
+              <a:rPr sz="1300" b="0" i="0" kern="0" spc="0">
                 <a:solidFill>
                   <a:srgbClr val="FFFFFF"/>
                 </a:solidFill>
@@ -4373,8 +4373,8 @@
         </p:nvSpPr>
         <p:spPr>
           <a:xfrm>
-            <a:off x="8001000" y="4762500"/>
-            <a:ext cx="8382000" cy="1905000"/>
+            <a:off x="10391775" y="4762500"/>
+            <a:ext cx="3600450" cy="1905000"/>
           </a:xfrm>
           <a:prstGeom prst="rect">
             <a:avLst/>
@@ -4408,23 +4408,23 @@
         </p:nvSpPr>
         <p:spPr>
           <a:xfrm>
-            <a:off x="8001000" y="6858000"/>
-            <a:ext cx="8382000" cy="1714500"/>
-          </a:xfrm>
-          <a:prstGeom prst="rect">
-            <a:avLst/>
-          </a:prstGeom>
-          <a:noFill/>
-        </p:spPr>
-        <p:txBody>
-          <a:bodyPr wrap="square" lIns="0" rIns="0" tIns="0" bIns="0">
-            <a:spAutoFit/>
-          </a:bodyPr>
-          <a:lstStyle/>
-          <a:p>
-            <a:pPr algn="ctr"/>
-            <a:r>
-              <a:rPr sz="1650" b="0" i="0" kern="0" spc="0">
+            <a:off x="10391775" y="6858000"/>
+            <a:ext cx="3600450" cy="1076325"/>
+          </a:xfrm>
+          <a:prstGeom prst="rect">
+            <a:avLst/>
+          </a:prstGeom>
+          <a:noFill/>
+        </p:spPr>
+        <p:txBody>
+          <a:bodyPr wrap="square" lIns="0" rIns="0" tIns="0" bIns="0">
+            <a:spAutoFit/>
+          </a:bodyPr>
+          <a:lstStyle/>
+          <a:p>
+            <a:pPr algn="ctr"/>
+            <a:r>
+              <a:rPr sz="1300" b="0" i="0" kern="0" spc="0">
                 <a:solidFill>
                   <a:srgbClr val="FFFFFF"/>
                 </a:solidFill>
@@ -4433,7 +4433,7 @@
               <a:t>dice que el </a:t>
             </a:r>
             <a:r>
-              <a:rPr sz="1650" b="1" i="0" kern="0" spc="0">
+              <a:rPr sz="1300" b="1" i="0" kern="0" spc="0">
                 <a:solidFill>
                   <a:srgbClr val="FFFFFF"/>
                 </a:solidFill>
@@ -4442,7 +4442,7 @@
               <a:t>cuidado de los hijos</a:t>
             </a:r>
             <a:r>
-              <a:rPr sz="1650" b="0" i="0" kern="0" spc="0">
+              <a:rPr sz="1300" b="0" i="0" kern="0" spc="0">
                 <a:solidFill>
                   <a:srgbClr val="FFFFFF"/>
                 </a:solidFill>
@@ -4697,7 +4697,7 @@
           <a:p>
             <a:pPr algn="ctr"/>
             <a:r>
-              <a:rPr sz="3150" b="0" i="0" kern="0" spc="0">
+              <a:rPr sz="5000" b="0" i="0" kern="0" spc="0">
                 <a:solidFill>
                   <a:srgbClr val="FFFFFF"/>
                 </a:solidFill>
@@ -4706,7 +4706,7 @@
               <a:t>76.7% DE LAS MUJERES DICE QUE EL ROL HA CAMBIADO MUCHO — 4.9 PUNTOS MÁS QUE LOS HOMBRES. </a:t>
             </a:r>
             <a:r>
-              <a:rPr sz="3150" b="0" i="1" kern="0" spc="0">
+              <a:rPr sz="5000" b="0" i="1" kern="0" spc="0">
                 <a:solidFill>
                   <a:srgbClr val="FFFFFF"/>
                 </a:solidFill>
@@ -4726,7 +4726,7 @@
         <p:spPr>
           <a:xfrm>
             <a:off x="6848475" y="4572000"/>
-            <a:ext cx="19050" cy="2647950"/>
+            <a:ext cx="19050" cy="1457325"/>
           </a:xfrm>
           <a:prstGeom prst="rect">
             <a:avLst/>
@@ -4769,7 +4769,7 @@
         <p:spPr>
           <a:xfrm>
             <a:off x="11420475" y="4572000"/>
-            <a:ext cx="19050" cy="2647950"/>
+            <a:ext cx="19050" cy="1457325"/>
           </a:xfrm>
           <a:prstGeom prst="rect">
             <a:avLst/>
@@ -4811,8 +4811,8 @@
         </p:nvSpPr>
         <p:spPr>
           <a:xfrm>
-            <a:off x="1905000" y="4762500"/>
-            <a:ext cx="5334000" cy="1905000"/>
+            <a:off x="2771775" y="4762500"/>
+            <a:ext cx="3600450" cy="1905000"/>
           </a:xfrm>
           <a:prstGeom prst="rect">
             <a:avLst/>
@@ -4846,23 +4846,23 @@
         </p:nvSpPr>
         <p:spPr>
           <a:xfrm>
-            <a:off x="1905000" y="6858000"/>
-            <a:ext cx="5334000" cy="1714500"/>
-          </a:xfrm>
-          <a:prstGeom prst="rect">
-            <a:avLst/>
-          </a:prstGeom>
-          <a:noFill/>
-        </p:spPr>
-        <p:txBody>
-          <a:bodyPr wrap="square" lIns="0" rIns="0" tIns="0" bIns="0">
-            <a:spAutoFit/>
-          </a:bodyPr>
-          <a:lstStyle/>
-          <a:p>
-            <a:pPr algn="ctr"/>
-            <a:r>
-              <a:rPr sz="1650" b="0" i="0" kern="0" spc="0">
+            <a:off x="2771775" y="6858000"/>
+            <a:ext cx="3600450" cy="1076325"/>
+          </a:xfrm>
+          <a:prstGeom prst="rect">
+            <a:avLst/>
+          </a:prstGeom>
+          <a:noFill/>
+        </p:spPr>
+        <p:txBody>
+          <a:bodyPr wrap="square" lIns="0" rIns="0" tIns="0" bIns="0">
+            <a:spAutoFit/>
+          </a:bodyPr>
+          <a:lstStyle/>
+          <a:p>
+            <a:pPr algn="ctr"/>
+            <a:r>
+              <a:rPr sz="1300" b="0" i="0" kern="0" spc="0">
                 <a:solidFill>
                   <a:srgbClr val="FFFFFF"/>
                 </a:solidFill>
@@ -4871,7 +4871,7 @@
               <a:t>del subset </a:t>
             </a:r>
             <a:r>
-              <a:rPr sz="1650" b="1" i="0" kern="0" spc="0">
+              <a:rPr sz="1300" b="1" i="0" kern="0" spc="0">
                 <a:solidFill>
                   <a:srgbClr val="FFFFFF"/>
                 </a:solidFill>
@@ -4880,7 +4880,7 @@
               <a:t>femenino</a:t>
             </a:r>
             <a:r>
-              <a:rPr sz="1650" b="0" i="0" kern="0" spc="0">
+              <a:rPr sz="1300" b="0" i="0" kern="0" spc="0">
                 <a:solidFill>
                   <a:srgbClr val="FFFFFF"/>
                 </a:solidFill>
@@ -4899,8 +4899,8 @@
         </p:nvSpPr>
         <p:spPr>
           <a:xfrm>
-            <a:off x="6477000" y="4762500"/>
-            <a:ext cx="5334000" cy="1905000"/>
+            <a:off x="7343775" y="4762500"/>
+            <a:ext cx="3600450" cy="1905000"/>
           </a:xfrm>
           <a:prstGeom prst="rect">
             <a:avLst/>
@@ -4934,23 +4934,23 @@
         </p:nvSpPr>
         <p:spPr>
           <a:xfrm>
-            <a:off x="6477000" y="6858000"/>
-            <a:ext cx="5334000" cy="1714500"/>
-          </a:xfrm>
-          <a:prstGeom prst="rect">
-            <a:avLst/>
-          </a:prstGeom>
-          <a:noFill/>
-        </p:spPr>
-        <p:txBody>
-          <a:bodyPr wrap="square" lIns="0" rIns="0" tIns="0" bIns="0">
-            <a:spAutoFit/>
-          </a:bodyPr>
-          <a:lstStyle/>
-          <a:p>
-            <a:pPr algn="ctr"/>
-            <a:r>
-              <a:rPr sz="1650" b="0" i="0" kern="0" spc="0">
+            <a:off x="7343775" y="6858000"/>
+            <a:ext cx="3600450" cy="1076325"/>
+          </a:xfrm>
+          <a:prstGeom prst="rect">
+            <a:avLst/>
+          </a:prstGeom>
+          <a:noFill/>
+        </p:spPr>
+        <p:txBody>
+          <a:bodyPr wrap="square" lIns="0" rIns="0" tIns="0" bIns="0">
+            <a:spAutoFit/>
+          </a:bodyPr>
+          <a:lstStyle/>
+          <a:p>
+            <a:pPr algn="ctr"/>
+            <a:r>
+              <a:rPr sz="1300" b="0" i="0" kern="0" spc="0">
                 <a:solidFill>
                   <a:srgbClr val="FFFFFF"/>
                 </a:solidFill>
@@ -4959,7 +4959,7 @@
               <a:t>del subset </a:t>
             </a:r>
             <a:r>
-              <a:rPr sz="1650" b="1" i="0" kern="0" spc="0">
+              <a:rPr sz="1300" b="1" i="0" kern="0" spc="0">
                 <a:solidFill>
                   <a:srgbClr val="FFFFFF"/>
                 </a:solidFill>
@@ -4968,7 +4968,7 @@
               <a:t>masculino</a:t>
             </a:r>
             <a:r>
-              <a:rPr sz="1650" b="0" i="0" kern="0" spc="0">
+              <a:rPr sz="1300" b="0" i="0" kern="0" spc="0">
                 <a:solidFill>
                   <a:srgbClr val="FFFFFF"/>
                 </a:solidFill>
@@ -4987,8 +4987,8 @@
         </p:nvSpPr>
         <p:spPr>
           <a:xfrm>
-            <a:off x="11049000" y="4762500"/>
-            <a:ext cx="5334000" cy="1905000"/>
+            <a:off x="11915775" y="4762500"/>
+            <a:ext cx="3600450" cy="1905000"/>
           </a:xfrm>
           <a:prstGeom prst="rect">
             <a:avLst/>
@@ -5022,23 +5022,23 @@
         </p:nvSpPr>
         <p:spPr>
           <a:xfrm>
-            <a:off x="11049000" y="6858000"/>
-            <a:ext cx="5334000" cy="1714500"/>
-          </a:xfrm>
-          <a:prstGeom prst="rect">
-            <a:avLst/>
-          </a:prstGeom>
-          <a:noFill/>
-        </p:spPr>
-        <p:txBody>
-          <a:bodyPr wrap="square" lIns="0" rIns="0" tIns="0" bIns="0">
-            <a:spAutoFit/>
-          </a:bodyPr>
-          <a:lstStyle/>
-          <a:p>
-            <a:pPr algn="ctr"/>
-            <a:r>
-              <a:rPr sz="1650" b="0" i="0" kern="0" spc="0">
+            <a:off x="11915775" y="6858000"/>
+            <a:ext cx="3600450" cy="1076325"/>
+          </a:xfrm>
+          <a:prstGeom prst="rect">
+            <a:avLst/>
+          </a:prstGeom>
+          <a:noFill/>
+        </p:spPr>
+        <p:txBody>
+          <a:bodyPr wrap="square" lIns="0" rIns="0" tIns="0" bIns="0">
+            <a:spAutoFit/>
+          </a:bodyPr>
+          <a:lstStyle/>
+          <a:p>
+            <a:pPr algn="ctr"/>
+            <a:r>
+              <a:rPr sz="1300" b="0" i="0" kern="0" spc="0">
                 <a:solidFill>
                   <a:srgbClr val="FFFFFF"/>
                 </a:solidFill>
@@ -5047,7 +5047,7 @@
               <a:t>del subset </a:t>
             </a:r>
             <a:r>
-              <a:rPr sz="1650" b="1" i="0" kern="0" spc="0">
+              <a:rPr sz="1300" b="1" i="0" kern="0" spc="0">
                 <a:solidFill>
                   <a:srgbClr val="FFFFFF"/>
                 </a:solidFill>
@@ -5056,7 +5056,7 @@
               <a:t>monoparental</a:t>
             </a:r>
             <a:r>
-              <a:rPr sz="1650" b="0" i="0" kern="0" spc="0">
+              <a:rPr sz="1300" b="0" i="0" kern="0" spc="0">
                 <a:solidFill>
                   <a:srgbClr val="FFFFFF"/>
                 </a:solidFill>
@@ -5311,7 +5311,7 @@
           <a:p>
             <a:pPr algn="ctr"/>
             <a:r>
-              <a:rPr sz="3150" b="0" i="0" kern="0" spc="0">
+              <a:rPr sz="5000" b="0" i="0" kern="0" spc="0">
                 <a:solidFill>
                   <a:srgbClr val="FFFFFF"/>
                 </a:solidFill>
@@ -5320,7 +5320,7 @@
               <a:t>36.4% DICE QUE LA COMPRA DEL SUPERMERCADO LA HACE MÁS ELLA; 48.4% DICE QUE LA HACEN AMBOS. </a:t>
             </a:r>
             <a:r>
-              <a:rPr sz="3150" b="0" i="1" kern="0" spc="0">
+              <a:rPr sz="5000" b="0" i="1" kern="0" spc="0">
                 <a:solidFill>
                   <a:srgbClr val="FFFFFF"/>
                 </a:solidFill>
@@ -5340,7 +5340,7 @@
         <p:spPr>
           <a:xfrm>
             <a:off x="9134475" y="4572000"/>
-            <a:ext cx="19050" cy="2647950"/>
+            <a:ext cx="19050" cy="1457325"/>
           </a:xfrm>
           <a:prstGeom prst="rect">
             <a:avLst/>
@@ -5382,8 +5382,8 @@
         </p:nvSpPr>
         <p:spPr>
           <a:xfrm>
-            <a:off x="1905000" y="4762500"/>
-            <a:ext cx="8382000" cy="1905000"/>
+            <a:off x="4295775" y="4762500"/>
+            <a:ext cx="3600450" cy="1905000"/>
           </a:xfrm>
           <a:prstGeom prst="rect">
             <a:avLst/>
@@ -5417,23 +5417,23 @@
         </p:nvSpPr>
         <p:spPr>
           <a:xfrm>
-            <a:off x="1905000" y="6858000"/>
-            <a:ext cx="8382000" cy="1714500"/>
-          </a:xfrm>
-          <a:prstGeom prst="rect">
-            <a:avLst/>
-          </a:prstGeom>
-          <a:noFill/>
-        </p:spPr>
-        <p:txBody>
-          <a:bodyPr wrap="square" lIns="0" rIns="0" tIns="0" bIns="0">
-            <a:spAutoFit/>
-          </a:bodyPr>
-          <a:lstStyle/>
-          <a:p>
-            <a:pPr algn="ctr"/>
-            <a:r>
-              <a:rPr sz="1650" b="0" i="0" kern="0" spc="0">
+            <a:off x="4295775" y="6858000"/>
+            <a:ext cx="3600450" cy="1076325"/>
+          </a:xfrm>
+          <a:prstGeom prst="rect">
+            <a:avLst/>
+          </a:prstGeom>
+          <a:noFill/>
+        </p:spPr>
+        <p:txBody>
+          <a:bodyPr wrap="square" lIns="0" rIns="0" tIns="0" bIns="0">
+            <a:spAutoFit/>
+          </a:bodyPr>
+          <a:lstStyle/>
+          <a:p>
+            <a:pPr algn="ctr"/>
+            <a:r>
+              <a:rPr sz="1300" b="0" i="0" kern="0" spc="0">
                 <a:solidFill>
                   <a:srgbClr val="FFFFFF"/>
                 </a:solidFill>
@@ -5442,7 +5442,7 @@
               <a:t>del subsample femenino dice que la compra del </a:t>
             </a:r>
             <a:r>
-              <a:rPr sz="1650" b="1" i="0" kern="0" spc="0">
+              <a:rPr sz="1300" b="1" i="0" kern="0" spc="0">
                 <a:solidFill>
                   <a:srgbClr val="FFFFFF"/>
                 </a:solidFill>
@@ -5451,7 +5451,7 @@
               <a:t>supermercado</a:t>
             </a:r>
             <a:r>
-              <a:rPr sz="1650" b="0" i="0" kern="0" spc="0">
+              <a:rPr sz="1300" b="0" i="0" kern="0" spc="0">
                 <a:solidFill>
                   <a:srgbClr val="FFFFFF"/>
                 </a:solidFill>
@@ -5470,8 +5470,8 @@
         </p:nvSpPr>
         <p:spPr>
           <a:xfrm>
-            <a:off x="8001000" y="4762500"/>
-            <a:ext cx="8382000" cy="1905000"/>
+            <a:off x="10391775" y="4762500"/>
+            <a:ext cx="3600450" cy="1905000"/>
           </a:xfrm>
           <a:prstGeom prst="rect">
             <a:avLst/>
@@ -5505,23 +5505,23 @@
         </p:nvSpPr>
         <p:spPr>
           <a:xfrm>
-            <a:off x="8001000" y="6858000"/>
-            <a:ext cx="8382000" cy="1714500"/>
-          </a:xfrm>
-          <a:prstGeom prst="rect">
-            <a:avLst/>
-          </a:prstGeom>
-          <a:noFill/>
-        </p:spPr>
-        <p:txBody>
-          <a:bodyPr wrap="square" lIns="0" rIns="0" tIns="0" bIns="0">
-            <a:spAutoFit/>
-          </a:bodyPr>
-          <a:lstStyle/>
-          <a:p>
-            <a:pPr algn="ctr"/>
-            <a:r>
-              <a:rPr sz="1650" b="0" i="0" kern="0" spc="0">
+            <a:off x="10391775" y="6858000"/>
+            <a:ext cx="3600450" cy="1076325"/>
+          </a:xfrm>
+          <a:prstGeom prst="rect">
+            <a:avLst/>
+          </a:prstGeom>
+          <a:noFill/>
+        </p:spPr>
+        <p:txBody>
+          <a:bodyPr wrap="square" lIns="0" rIns="0" tIns="0" bIns="0">
+            <a:spAutoFit/>
+          </a:bodyPr>
+          <a:lstStyle/>
+          <a:p>
+            <a:pPr algn="ctr"/>
+            <a:r>
+              <a:rPr sz="1300" b="0" i="0" kern="0" spc="0">
                 <a:solidFill>
                   <a:srgbClr val="FFFFFF"/>
                 </a:solidFill>
@@ -5530,7 +5530,7 @@
               <a:t>dice que la compra de artículos </a:t>
             </a:r>
             <a:r>
-              <a:rPr sz="1650" b="1" i="0" kern="0" spc="0">
+              <a:rPr sz="1300" b="1" i="0" kern="0" spc="0">
                 <a:solidFill>
                   <a:srgbClr val="FFFFFF"/>
                 </a:solidFill>
@@ -5539,7 +5539,7 @@
               <a:t>personales o escolares</a:t>
             </a:r>
             <a:r>
-              <a:rPr sz="1650" b="0" i="0" kern="0" spc="0">
+              <a:rPr sz="1300" b="0" i="0" kern="0" spc="0">
                 <a:solidFill>
                   <a:srgbClr val="FFFFFF"/>
                 </a:solidFill>
@@ -5794,7 +5794,7 @@
           <a:p>
             <a:pPr algn="ctr"/>
             <a:r>
-              <a:rPr sz="3150" b="0" i="0" kern="0" spc="0">
+              <a:rPr sz="5000" b="0" i="0" kern="0" spc="0">
                 <a:solidFill>
                   <a:srgbClr val="FFFFFF"/>
                 </a:solidFill>
@@ -5803,7 +5803,7 @@
               <a:t>47.8% DE LAS MUJERES NOMBRA LA ECONOMÍA COMO SU MAYOR FUENTE DE ESTRÉS FAMILIAR. </a:t>
             </a:r>
             <a:r>
-              <a:rPr sz="3150" b="0" i="1" kern="0" spc="0">
+              <a:rPr sz="5000" b="0" i="1" kern="0" spc="0">
                 <a:solidFill>
                   <a:srgbClr val="FFFFFF"/>
                 </a:solidFill>
@@ -5823,7 +5823,7 @@
         <p:spPr>
           <a:xfrm>
             <a:off x="9134475" y="4572000"/>
-            <a:ext cx="19050" cy="2647950"/>
+            <a:ext cx="19050" cy="1457325"/>
           </a:xfrm>
           <a:prstGeom prst="rect">
             <a:avLst/>
@@ -5865,8 +5865,8 @@
         </p:nvSpPr>
         <p:spPr>
           <a:xfrm>
-            <a:off x="1905000" y="4762500"/>
-            <a:ext cx="8382000" cy="1905000"/>
+            <a:off x="4295775" y="4762500"/>
+            <a:ext cx="3600450" cy="1905000"/>
           </a:xfrm>
           <a:prstGeom prst="rect">
             <a:avLst/>
@@ -5900,23 +5900,23 @@
         </p:nvSpPr>
         <p:spPr>
           <a:xfrm>
-            <a:off x="1905000" y="6858000"/>
-            <a:ext cx="8382000" cy="1714500"/>
-          </a:xfrm>
-          <a:prstGeom prst="rect">
-            <a:avLst/>
-          </a:prstGeom>
-          <a:noFill/>
-        </p:spPr>
-        <p:txBody>
-          <a:bodyPr wrap="square" lIns="0" rIns="0" tIns="0" bIns="0">
-            <a:spAutoFit/>
-          </a:bodyPr>
-          <a:lstStyle/>
-          <a:p>
-            <a:pPr algn="ctr"/>
-            <a:r>
-              <a:rPr sz="1650" b="0" i="0" kern="0" spc="0">
+            <a:off x="4295775" y="6858000"/>
+            <a:ext cx="3600450" cy="1076325"/>
+          </a:xfrm>
+          <a:prstGeom prst="rect">
+            <a:avLst/>
+          </a:prstGeom>
+          <a:noFill/>
+        </p:spPr>
+        <p:txBody>
+          <a:bodyPr wrap="square" lIns="0" rIns="0" tIns="0" bIns="0">
+            <a:spAutoFit/>
+          </a:bodyPr>
+          <a:lstStyle/>
+          <a:p>
+            <a:pPr algn="ctr"/>
+            <a:r>
+              <a:rPr sz="1300" b="0" i="0" kern="0" spc="0">
                 <a:solidFill>
                   <a:srgbClr val="FFFFFF"/>
                 </a:solidFill>
@@ -5925,7 +5925,7 @@
               <a:t>del subsample femenino (n=305) marca “</a:t>
             </a:r>
             <a:r>
-              <a:rPr sz="1650" b="1" i="0" kern="0" spc="0">
+              <a:rPr sz="1300" b="1" i="0" kern="0" spc="0">
                 <a:solidFill>
                   <a:srgbClr val="FFFFFF"/>
                 </a:solidFill>
@@ -5934,7 +5934,7 @@
               <a:t>Economía</a:t>
             </a:r>
             <a:r>
-              <a:rPr sz="1650" b="0" i="0" kern="0" spc="0">
+              <a:rPr sz="1300" b="0" i="0" kern="0" spc="0">
                 <a:solidFill>
                   <a:srgbClr val="FFFFFF"/>
                 </a:solidFill>
@@ -5953,8 +5953,8 @@
         </p:nvSpPr>
         <p:spPr>
           <a:xfrm>
-            <a:off x="8001000" y="4762500"/>
-            <a:ext cx="8382000" cy="1905000"/>
+            <a:off x="10391775" y="4762500"/>
+            <a:ext cx="3600450" cy="1905000"/>
           </a:xfrm>
           <a:prstGeom prst="rect">
             <a:avLst/>
@@ -5988,23 +5988,23 @@
         </p:nvSpPr>
         <p:spPr>
           <a:xfrm>
-            <a:off x="8001000" y="6858000"/>
-            <a:ext cx="8382000" cy="1714500"/>
-          </a:xfrm>
-          <a:prstGeom prst="rect">
-            <a:avLst/>
-          </a:prstGeom>
-          <a:noFill/>
-        </p:spPr>
-        <p:txBody>
-          <a:bodyPr wrap="square" lIns="0" rIns="0" tIns="0" bIns="0">
-            <a:spAutoFit/>
-          </a:bodyPr>
-          <a:lstStyle/>
-          <a:p>
-            <a:pPr algn="ctr"/>
-            <a:r>
-              <a:rPr sz="1650" b="0" i="0" kern="0" spc="0">
+            <a:off x="10391775" y="6858000"/>
+            <a:ext cx="3600450" cy="1076325"/>
+          </a:xfrm>
+          <a:prstGeom prst="rect">
+            <a:avLst/>
+          </a:prstGeom>
+          <a:noFill/>
+        </p:spPr>
+        <p:txBody>
+          <a:bodyPr wrap="square" lIns="0" rIns="0" tIns="0" bIns="0">
+            <a:spAutoFit/>
+          </a:bodyPr>
+          <a:lstStyle/>
+          <a:p>
+            <a:pPr algn="ctr"/>
+            <a:r>
+              <a:rPr sz="1300" b="0" i="0" kern="0" spc="0">
                 <a:solidFill>
                   <a:srgbClr val="FFFFFF"/>
                 </a:solidFill>
@@ -6013,7 +6013,7 @@
               <a:t>marca “</a:t>
             </a:r>
             <a:r>
-              <a:rPr sz="1650" b="1" i="0" kern="0" spc="0">
+              <a:rPr sz="1300" b="1" i="0" kern="0" spc="0">
                 <a:solidFill>
                   <a:srgbClr val="FFFFFF"/>
                 </a:solidFill>
@@ -6022,7 +6022,7 @@
               <a:t>Inseguridad</a:t>
             </a:r>
             <a:r>
-              <a:rPr sz="1650" b="0" i="0" kern="0" spc="0">
+              <a:rPr sz="1300" b="0" i="0" kern="0" spc="0">
                 <a:solidFill>
                   <a:srgbClr val="FFFFFF"/>
                 </a:solidFill>
@@ -6436,7 +6436,7 @@
           <a:p>
             <a:pPr algn="ctr"/>
             <a:r>
-              <a:rPr sz="3150" b="0" i="0" kern="0" spc="0">
+              <a:rPr sz="5000" b="0" i="0" kern="0" spc="0">
                 <a:solidFill>
                   <a:srgbClr val="FFFFFF"/>
                 </a:solidFill>
@@ -6445,7 +6445,7 @@
               <a:t>48.5% DE LAS MUJERES NO REALIZA NINGUNA ACTIVIDAD PARA CUIDAR SU SALUD MENTAL NI FÍSICA. </a:t>
             </a:r>
             <a:r>
-              <a:rPr sz="3150" b="0" i="1" kern="0" spc="0">
+              <a:rPr sz="5000" b="0" i="1" kern="0" spc="0">
                 <a:solidFill>
                   <a:srgbClr val="FFFFFF"/>
                 </a:solidFill>
@@ -6465,7 +6465,7 @@
         <p:spPr>
           <a:xfrm>
             <a:off x="6848475" y="4572000"/>
-            <a:ext cx="19050" cy="2647950"/>
+            <a:ext cx="19050" cy="1457325"/>
           </a:xfrm>
           <a:prstGeom prst="rect">
             <a:avLst/>
@@ -6508,7 +6508,7 @@
         <p:spPr>
           <a:xfrm>
             <a:off x="11420475" y="4572000"/>
-            <a:ext cx="19050" cy="2647950"/>
+            <a:ext cx="19050" cy="1457325"/>
           </a:xfrm>
           <a:prstGeom prst="rect">
             <a:avLst/>
@@ -6550,8 +6550,8 @@
         </p:nvSpPr>
         <p:spPr>
           <a:xfrm>
-            <a:off x="1905000" y="4762500"/>
-            <a:ext cx="5334000" cy="1905000"/>
+            <a:off x="2771775" y="4762500"/>
+            <a:ext cx="3600450" cy="1905000"/>
           </a:xfrm>
           <a:prstGeom prst="rect">
             <a:avLst/>
@@ -6585,23 +6585,23 @@
         </p:nvSpPr>
         <p:spPr>
           <a:xfrm>
-            <a:off x="1905000" y="6858000"/>
-            <a:ext cx="5334000" cy="1714500"/>
-          </a:xfrm>
-          <a:prstGeom prst="rect">
-            <a:avLst/>
-          </a:prstGeom>
-          <a:noFill/>
-        </p:spPr>
-        <p:txBody>
-          <a:bodyPr wrap="square" lIns="0" rIns="0" tIns="0" bIns="0">
-            <a:spAutoFit/>
-          </a:bodyPr>
-          <a:lstStyle/>
-          <a:p>
-            <a:pPr algn="ctr"/>
-            <a:r>
-              <a:rPr sz="1650" b="0" i="0" kern="0" spc="0">
+            <a:off x="2771775" y="6858000"/>
+            <a:ext cx="3600450" cy="1076325"/>
+          </a:xfrm>
+          <a:prstGeom prst="rect">
+            <a:avLst/>
+          </a:prstGeom>
+          <a:noFill/>
+        </p:spPr>
+        <p:txBody>
+          <a:bodyPr wrap="square" lIns="0" rIns="0" tIns="0" bIns="0">
+            <a:spAutoFit/>
+          </a:bodyPr>
+          <a:lstStyle/>
+          <a:p>
+            <a:pPr algn="ctr"/>
+            <a:r>
+              <a:rPr sz="1300" b="0" i="0" kern="0" spc="0">
                 <a:solidFill>
                   <a:srgbClr val="FFFFFF"/>
                 </a:solidFill>
@@ -6610,7 +6610,7 @@
               <a:t>del subset </a:t>
             </a:r>
             <a:r>
-              <a:rPr sz="1650" b="1" i="0" kern="0" spc="0">
+              <a:rPr sz="1300" b="1" i="0" kern="0" spc="0">
                 <a:solidFill>
                   <a:srgbClr val="FFFFFF"/>
                 </a:solidFill>
@@ -6619,7 +6619,7 @@
               <a:t>femenino</a:t>
             </a:r>
             <a:r>
-              <a:rPr sz="1650" b="0" i="0" kern="0" spc="0">
+              <a:rPr sz="1300" b="0" i="0" kern="0" spc="0">
                 <a:solidFill>
                   <a:srgbClr val="FFFFFF"/>
                 </a:solidFill>
@@ -6638,8 +6638,8 @@
         </p:nvSpPr>
         <p:spPr>
           <a:xfrm>
-            <a:off x="6477000" y="4762500"/>
-            <a:ext cx="5334000" cy="1905000"/>
+            <a:off x="7343775" y="4762500"/>
+            <a:ext cx="3600450" cy="1905000"/>
           </a:xfrm>
           <a:prstGeom prst="rect">
             <a:avLst/>
@@ -6673,23 +6673,23 @@
         </p:nvSpPr>
         <p:spPr>
           <a:xfrm>
-            <a:off x="6477000" y="6858000"/>
-            <a:ext cx="5334000" cy="1714500"/>
-          </a:xfrm>
-          <a:prstGeom prst="rect">
-            <a:avLst/>
-          </a:prstGeom>
-          <a:noFill/>
-        </p:spPr>
-        <p:txBody>
-          <a:bodyPr wrap="square" lIns="0" rIns="0" tIns="0" bIns="0">
-            <a:spAutoFit/>
-          </a:bodyPr>
-          <a:lstStyle/>
-          <a:p>
-            <a:pPr algn="ctr"/>
-            <a:r>
-              <a:rPr sz="1650" b="0" i="0" kern="0" spc="0">
+            <a:off x="7343775" y="6858000"/>
+            <a:ext cx="3600450" cy="1076325"/>
+          </a:xfrm>
+          <a:prstGeom prst="rect">
+            <a:avLst/>
+          </a:prstGeom>
+          <a:noFill/>
+        </p:spPr>
+        <p:txBody>
+          <a:bodyPr wrap="square" lIns="0" rIns="0" tIns="0" bIns="0">
+            <a:spAutoFit/>
+          </a:bodyPr>
+          <a:lstStyle/>
+          <a:p>
+            <a:pPr algn="ctr"/>
+            <a:r>
+              <a:rPr sz="1300" b="0" i="0" kern="0" spc="0">
                 <a:solidFill>
                   <a:srgbClr val="FFFFFF"/>
                 </a:solidFill>
@@ -6698,7 +6698,7 @@
               <a:t>del subset femenino </a:t>
             </a:r>
             <a:r>
-              <a:rPr sz="1650" b="1" i="0" kern="0" spc="0">
+              <a:rPr sz="1300" b="1" i="0" kern="0" spc="0">
                 <a:solidFill>
                   <a:srgbClr val="FFFFFF"/>
                 </a:solidFill>
@@ -6707,7 +6707,7 @@
               <a:t>18-24 años</a:t>
             </a:r>
             <a:r>
-              <a:rPr sz="1650" b="0" i="0" kern="0" spc="0">
+              <a:rPr sz="1300" b="0" i="0" kern="0" spc="0">
                 <a:solidFill>
                   <a:srgbClr val="FFFFFF"/>
                 </a:solidFill>
@@ -6726,8 +6726,8 @@
         </p:nvSpPr>
         <p:spPr>
           <a:xfrm>
-            <a:off x="11049000" y="4762500"/>
-            <a:ext cx="5334000" cy="1905000"/>
+            <a:off x="11915775" y="4762500"/>
+            <a:ext cx="3600450" cy="1905000"/>
           </a:xfrm>
           <a:prstGeom prst="rect">
             <a:avLst/>
@@ -6761,23 +6761,23 @@
         </p:nvSpPr>
         <p:spPr>
           <a:xfrm>
-            <a:off x="11049000" y="6858000"/>
-            <a:ext cx="5334000" cy="1714500"/>
-          </a:xfrm>
-          <a:prstGeom prst="rect">
-            <a:avLst/>
-          </a:prstGeom>
-          <a:noFill/>
-        </p:spPr>
-        <p:txBody>
-          <a:bodyPr wrap="square" lIns="0" rIns="0" tIns="0" bIns="0">
-            <a:spAutoFit/>
-          </a:bodyPr>
-          <a:lstStyle/>
-          <a:p>
-            <a:pPr algn="ctr"/>
-            <a:r>
-              <a:rPr sz="1650" b="0" i="0" kern="0" spc="0">
+            <a:off x="11915775" y="6858000"/>
+            <a:ext cx="3600450" cy="1076325"/>
+          </a:xfrm>
+          <a:prstGeom prst="rect">
+            <a:avLst/>
+          </a:prstGeom>
+          <a:noFill/>
+        </p:spPr>
+        <p:txBody>
+          <a:bodyPr wrap="square" lIns="0" rIns="0" tIns="0" bIns="0">
+            <a:spAutoFit/>
+          </a:bodyPr>
+          <a:lstStyle/>
+          <a:p>
+            <a:pPr algn="ctr"/>
+            <a:r>
+              <a:rPr sz="1300" b="0" i="0" kern="0" spc="0">
                 <a:solidFill>
                   <a:srgbClr val="FFFFFF"/>
                 </a:solidFill>
@@ -6786,7 +6786,7 @@
               <a:t>del subset </a:t>
             </a:r>
             <a:r>
-              <a:rPr sz="1650" b="1" i="0" kern="0" spc="0">
+              <a:rPr sz="1300" b="1" i="0" kern="0" spc="0">
                 <a:solidFill>
                   <a:srgbClr val="FFFFFF"/>
                 </a:solidFill>
@@ -6795,7 +6795,7 @@
               <a:t>NSE D</a:t>
             </a:r>
             <a:r>
-              <a:rPr sz="1650" b="0" i="0" kern="0" spc="0">
+              <a:rPr sz="1300" b="0" i="0" kern="0" spc="0">
                 <a:solidFill>
                   <a:srgbClr val="FFFFFF"/>
                 </a:solidFill>
@@ -7050,7 +7050,7 @@
           <a:p>
             <a:pPr algn="ctr"/>
             <a:r>
-              <a:rPr sz="3150" b="0" i="0" kern="0" spc="0">
+              <a:rPr sz="5000" b="0" i="0" kern="0" spc="0">
                 <a:solidFill>
                   <a:srgbClr val="FFFFFF"/>
                 </a:solidFill>
@@ -7059,7 +7059,7 @@
               <a:t>56.6% DEL MONOPARENTAL CITA A LA MADRE COMO ÚNICA RESPONSABLE DE CRIANZA — 14.8 PUNTOS SOBRE EL PROMEDIO. </a:t>
             </a:r>
             <a:r>
-              <a:rPr sz="3150" b="0" i="1" kern="0" spc="0">
+              <a:rPr sz="5000" b="0" i="1" kern="0" spc="0">
                 <a:solidFill>
                   <a:srgbClr val="FFFFFF"/>
                 </a:solidFill>
@@ -7079,7 +7079,7 @@
         <p:spPr>
           <a:xfrm>
             <a:off x="9134475" y="4572000"/>
-            <a:ext cx="19050" cy="2647950"/>
+            <a:ext cx="19050" cy="1457325"/>
           </a:xfrm>
           <a:prstGeom prst="rect">
             <a:avLst/>
@@ -7121,8 +7121,8 @@
         </p:nvSpPr>
         <p:spPr>
           <a:xfrm>
-            <a:off x="1905000" y="4762500"/>
-            <a:ext cx="8382000" cy="1905000"/>
+            <a:off x="4295775" y="4762500"/>
+            <a:ext cx="3600450" cy="1905000"/>
           </a:xfrm>
           <a:prstGeom prst="rect">
             <a:avLst/>
@@ -7156,23 +7156,23 @@
         </p:nvSpPr>
         <p:spPr>
           <a:xfrm>
-            <a:off x="1905000" y="6858000"/>
-            <a:ext cx="8382000" cy="1714500"/>
-          </a:xfrm>
-          <a:prstGeom prst="rect">
-            <a:avLst/>
-          </a:prstGeom>
-          <a:noFill/>
-        </p:spPr>
-        <p:txBody>
-          <a:bodyPr wrap="square" lIns="0" rIns="0" tIns="0" bIns="0">
-            <a:spAutoFit/>
-          </a:bodyPr>
-          <a:lstStyle/>
-          <a:p>
-            <a:pPr algn="ctr"/>
-            <a:r>
-              <a:rPr sz="1650" b="0" i="0" kern="0" spc="0">
+            <a:off x="4295775" y="6858000"/>
+            <a:ext cx="3600450" cy="1076325"/>
+          </a:xfrm>
+          <a:prstGeom prst="rect">
+            <a:avLst/>
+          </a:prstGeom>
+          <a:noFill/>
+        </p:spPr>
+        <p:txBody>
+          <a:bodyPr wrap="square" lIns="0" rIns="0" tIns="0" bIns="0">
+            <a:spAutoFit/>
+          </a:bodyPr>
+          <a:lstStyle/>
+          <a:p>
+            <a:pPr algn="ctr"/>
+            <a:r>
+              <a:rPr sz="1300" b="0" i="0" kern="0" spc="0">
                 <a:solidFill>
                   <a:srgbClr val="FFFFFF"/>
                 </a:solidFill>
@@ -7181,7 +7181,7 @@
               <a:t>del total Código Casa (n=500) declara hogar </a:t>
             </a:r>
             <a:r>
-              <a:rPr sz="1650" b="1" i="0" kern="0" spc="0">
+              <a:rPr sz="1300" b="1" i="0" kern="0" spc="0">
                 <a:solidFill>
                   <a:srgbClr val="FFFFFF"/>
                 </a:solidFill>
@@ -7190,7 +7190,7 @@
               <a:t>monoparental</a:t>
             </a:r>
             <a:r>
-              <a:rPr sz="1650" b="0" i="0" kern="0" spc="0">
+              <a:rPr sz="1300" b="0" i="0" kern="0" spc="0">
                 <a:solidFill>
                   <a:srgbClr val="FFFFFF"/>
                 </a:solidFill>
@@ -7209,8 +7209,8 @@
         </p:nvSpPr>
         <p:spPr>
           <a:xfrm>
-            <a:off x="8001000" y="4762500"/>
-            <a:ext cx="8382000" cy="1905000"/>
+            <a:off x="10391775" y="4762500"/>
+            <a:ext cx="3600450" cy="1905000"/>
           </a:xfrm>
           <a:prstGeom prst="rect">
             <a:avLst/>
@@ -7244,23 +7244,23 @@
         </p:nvSpPr>
         <p:spPr>
           <a:xfrm>
-            <a:off x="8001000" y="6858000"/>
-            <a:ext cx="8382000" cy="1714500"/>
-          </a:xfrm>
-          <a:prstGeom prst="rect">
-            <a:avLst/>
-          </a:prstGeom>
-          <a:noFill/>
-        </p:spPr>
-        <p:txBody>
-          <a:bodyPr wrap="square" lIns="0" rIns="0" tIns="0" bIns="0">
-            <a:spAutoFit/>
-          </a:bodyPr>
-          <a:lstStyle/>
-          <a:p>
-            <a:pPr algn="ctr"/>
-            <a:r>
-              <a:rPr sz="1650" b="0" i="0" kern="0" spc="0">
+            <a:off x="10391775" y="6858000"/>
+            <a:ext cx="3600450" cy="1076325"/>
+          </a:xfrm>
+          <a:prstGeom prst="rect">
+            <a:avLst/>
+          </a:prstGeom>
+          <a:noFill/>
+        </p:spPr>
+        <p:txBody>
+          <a:bodyPr wrap="square" lIns="0" rIns="0" tIns="0" bIns="0">
+            <a:spAutoFit/>
+          </a:bodyPr>
+          <a:lstStyle/>
+          <a:p>
+            <a:pPr algn="ctr"/>
+            <a:r>
+              <a:rPr sz="1300" b="0" i="0" kern="0" spc="0">
                 <a:solidFill>
                   <a:srgbClr val="FFFFFF"/>
                 </a:solidFill>
@@ -7269,7 +7269,7 @@
               <a:t>del subset monoparental (n=122) cita “</a:t>
             </a:r>
             <a:r>
-              <a:rPr sz="1650" b="1" i="0" kern="0" spc="0">
+              <a:rPr sz="1300" b="1" i="0" kern="0" spc="0">
                 <a:solidFill>
                   <a:srgbClr val="FFFFFF"/>
                 </a:solidFill>
@@ -7278,7 +7278,7 @@
               <a:t>Madre</a:t>
             </a:r>
             <a:r>
-              <a:rPr sz="1650" b="0" i="0" kern="0" spc="0">
+              <a:rPr sz="1300" b="0" i="0" kern="0" spc="0">
                 <a:solidFill>
                   <a:srgbClr val="FFFFFF"/>
                 </a:solidFill>
@@ -7533,7 +7533,7 @@
           <a:p>
             <a:pPr algn="ctr"/>
             <a:r>
-              <a:rPr sz="3150" b="0" i="0" kern="0" spc="0">
+              <a:rPr sz="5000" b="0" i="0" kern="0" spc="0">
                 <a:solidFill>
                   <a:srgbClr val="FFFFFF"/>
                 </a:solidFill>
@@ -7542,7 +7542,7 @@
               <a:t>LA MUJER 18-24 ES LA QUE MENOS SE CUIDA: 60.0% NO HACE NINGUNA ACTIVIDAD PARA SU SALUD. </a:t>
             </a:r>
             <a:r>
-              <a:rPr sz="3150" b="0" i="1" kern="0" spc="0">
+              <a:rPr sz="5000" b="0" i="1" kern="0" spc="0">
                 <a:solidFill>
                   <a:srgbClr val="FFFFFF"/>
                 </a:solidFill>
@@ -7562,7 +7562,7 @@
         <p:spPr>
           <a:xfrm>
             <a:off x="6848475" y="4572000"/>
-            <a:ext cx="19050" cy="2647950"/>
+            <a:ext cx="19050" cy="1457325"/>
           </a:xfrm>
           <a:prstGeom prst="rect">
             <a:avLst/>
@@ -7605,7 +7605,7 @@
         <p:spPr>
           <a:xfrm>
             <a:off x="11420475" y="4572000"/>
-            <a:ext cx="19050" cy="2647950"/>
+            <a:ext cx="19050" cy="1457325"/>
           </a:xfrm>
           <a:prstGeom prst="rect">
             <a:avLst/>
@@ -7647,8 +7647,8 @@
         </p:nvSpPr>
         <p:spPr>
           <a:xfrm>
-            <a:off x="1905000" y="4762500"/>
-            <a:ext cx="5334000" cy="1905000"/>
+            <a:off x="2771775" y="4762500"/>
+            <a:ext cx="3600450" cy="1905000"/>
           </a:xfrm>
           <a:prstGeom prst="rect">
             <a:avLst/>
@@ -7682,23 +7682,23 @@
         </p:nvSpPr>
         <p:spPr>
           <a:xfrm>
-            <a:off x="1905000" y="6858000"/>
-            <a:ext cx="5334000" cy="1714500"/>
-          </a:xfrm>
-          <a:prstGeom prst="rect">
-            <a:avLst/>
-          </a:prstGeom>
-          <a:noFill/>
-        </p:spPr>
-        <p:txBody>
-          <a:bodyPr wrap="square" lIns="0" rIns="0" tIns="0" bIns="0">
-            <a:spAutoFit/>
-          </a:bodyPr>
-          <a:lstStyle/>
-          <a:p>
-            <a:pPr algn="ctr"/>
-            <a:r>
-              <a:rPr sz="1650" b="0" i="0" kern="0" spc="0">
+            <a:off x="2771775" y="6858000"/>
+            <a:ext cx="3600450" cy="1076325"/>
+          </a:xfrm>
+          <a:prstGeom prst="rect">
+            <a:avLst/>
+          </a:prstGeom>
+          <a:noFill/>
+        </p:spPr>
+        <p:txBody>
+          <a:bodyPr wrap="square" lIns="0" rIns="0" tIns="0" bIns="0">
+            <a:spAutoFit/>
+          </a:bodyPr>
+          <a:lstStyle/>
+          <a:p>
+            <a:pPr algn="ctr"/>
+            <a:r>
+              <a:rPr sz="1300" b="0" i="0" kern="0" spc="0">
                 <a:solidFill>
                   <a:srgbClr val="FFFFFF"/>
                 </a:solidFill>
@@ -7707,7 +7707,7 @@
               <a:t>del subset femenino </a:t>
             </a:r>
             <a:r>
-              <a:rPr sz="1650" b="1" i="0" kern="0" spc="0">
+              <a:rPr sz="1300" b="1" i="0" kern="0" spc="0">
                 <a:solidFill>
                   <a:srgbClr val="FFFFFF"/>
                 </a:solidFill>
@@ -7716,7 +7716,7 @@
               <a:t>18-24 años</a:t>
             </a:r>
             <a:r>
-              <a:rPr sz="1650" b="0" i="0" kern="0" spc="0">
+              <a:rPr sz="1300" b="0" i="0" kern="0" spc="0">
                 <a:solidFill>
                   <a:srgbClr val="FFFFFF"/>
                 </a:solidFill>
@@ -7735,8 +7735,8 @@
         </p:nvSpPr>
         <p:spPr>
           <a:xfrm>
-            <a:off x="6477000" y="4762500"/>
-            <a:ext cx="5334000" cy="1905000"/>
+            <a:off x="7343775" y="4762500"/>
+            <a:ext cx="3600450" cy="1905000"/>
           </a:xfrm>
           <a:prstGeom prst="rect">
             <a:avLst/>
@@ -7770,23 +7770,23 @@
         </p:nvSpPr>
         <p:spPr>
           <a:xfrm>
-            <a:off x="6477000" y="6858000"/>
-            <a:ext cx="5334000" cy="1714500"/>
-          </a:xfrm>
-          <a:prstGeom prst="rect">
-            <a:avLst/>
-          </a:prstGeom>
-          <a:noFill/>
-        </p:spPr>
-        <p:txBody>
-          <a:bodyPr wrap="square" lIns="0" rIns="0" tIns="0" bIns="0">
-            <a:spAutoFit/>
-          </a:bodyPr>
-          <a:lstStyle/>
-          <a:p>
-            <a:pPr algn="ctr"/>
-            <a:r>
-              <a:rPr sz="1650" b="0" i="0" kern="0" spc="0">
+            <a:off x="7343775" y="6858000"/>
+            <a:ext cx="3600450" cy="1076325"/>
+          </a:xfrm>
+          <a:prstGeom prst="rect">
+            <a:avLst/>
+          </a:prstGeom>
+          <a:noFill/>
+        </p:spPr>
+        <p:txBody>
+          <a:bodyPr wrap="square" lIns="0" rIns="0" tIns="0" bIns="0">
+            <a:spAutoFit/>
+          </a:bodyPr>
+          <a:lstStyle/>
+          <a:p>
+            <a:pPr algn="ctr"/>
+            <a:r>
+              <a:rPr sz="1300" b="0" i="0" kern="0" spc="0">
                 <a:solidFill>
                   <a:srgbClr val="FFFFFF"/>
                 </a:solidFill>
@@ -7795,7 +7795,7 @@
               <a:t>del subset </a:t>
             </a:r>
             <a:r>
-              <a:rPr sz="1650" b="1" i="0" kern="0" spc="0">
+              <a:rPr sz="1300" b="1" i="0" kern="0" spc="0">
                 <a:solidFill>
                   <a:srgbClr val="FFFFFF"/>
                 </a:solidFill>
@@ -7804,7 +7804,7 @@
               <a:t>25-34 años</a:t>
             </a:r>
             <a:r>
-              <a:rPr sz="1650" b="0" i="0" kern="0" spc="0">
+              <a:rPr sz="1300" b="0" i="0" kern="0" spc="0">
                 <a:solidFill>
                   <a:srgbClr val="FFFFFF"/>
                 </a:solidFill>
@@ -7823,8 +7823,8 @@
         </p:nvSpPr>
         <p:spPr>
           <a:xfrm>
-            <a:off x="11049000" y="4762500"/>
-            <a:ext cx="5334000" cy="1905000"/>
+            <a:off x="11915775" y="4762500"/>
+            <a:ext cx="3600450" cy="1905000"/>
           </a:xfrm>
           <a:prstGeom prst="rect">
             <a:avLst/>
@@ -7858,23 +7858,23 @@
         </p:nvSpPr>
         <p:spPr>
           <a:xfrm>
-            <a:off x="11049000" y="6858000"/>
-            <a:ext cx="5334000" cy="1714500"/>
-          </a:xfrm>
-          <a:prstGeom prst="rect">
-            <a:avLst/>
-          </a:prstGeom>
-          <a:noFill/>
-        </p:spPr>
-        <p:txBody>
-          <a:bodyPr wrap="square" lIns="0" rIns="0" tIns="0" bIns="0">
-            <a:spAutoFit/>
-          </a:bodyPr>
-          <a:lstStyle/>
-          <a:p>
-            <a:pPr algn="ctr"/>
-            <a:r>
-              <a:rPr sz="1650" b="0" i="0" kern="0" spc="0">
+            <a:off x="11915775" y="6858000"/>
+            <a:ext cx="3600450" cy="1076325"/>
+          </a:xfrm>
+          <a:prstGeom prst="rect">
+            <a:avLst/>
+          </a:prstGeom>
+          <a:noFill/>
+        </p:spPr>
+        <p:txBody>
+          <a:bodyPr wrap="square" lIns="0" rIns="0" tIns="0" bIns="0">
+            <a:spAutoFit/>
+          </a:bodyPr>
+          <a:lstStyle/>
+          <a:p>
+            <a:pPr algn="ctr"/>
+            <a:r>
+              <a:rPr sz="1300" b="0" i="0" kern="0" spc="0">
                 <a:solidFill>
                   <a:srgbClr val="FFFFFF"/>
                 </a:solidFill>
@@ -7883,7 +7883,7 @@
               <a:t>del subset </a:t>
             </a:r>
             <a:r>
-              <a:rPr sz="1650" b="1" i="0" kern="0" spc="0">
+              <a:rPr sz="1300" b="1" i="0" kern="0" spc="0">
                 <a:solidFill>
                   <a:srgbClr val="FFFFFF"/>
                 </a:solidFill>
@@ -7892,7 +7892,7 @@
               <a:t>55+</a:t>
             </a:r>
             <a:r>
-              <a:rPr sz="1650" b="0" i="0" kern="0" spc="0">
+              <a:rPr sz="1300" b="0" i="0" kern="0" spc="0">
                 <a:solidFill>
                   <a:srgbClr val="FFFFFF"/>
                 </a:solidFill>
@@ -7988,7 +7988,7 @@
           <a:p>
             <a:pPr algn="ctr"/>
             <a:r>
-              <a:rPr sz="3150" b="0" i="0" kern="0" spc="0">
+              <a:rPr sz="5000" b="0" i="0" kern="0" spc="0">
                 <a:solidFill>
                   <a:srgbClr val="FFFFFF"/>
                 </a:solidFill>
@@ -7997,7 +7997,7 @@
               <a:t>LA MUJER DOMINICANA DECIDE LA CRIANZA, LA COCINA, LA LIMPIEZA Y EL CUIDADO. EL DINERO DEL HOGAR LO CO-GESTIONA. </a:t>
             </a:r>
             <a:r>
-              <a:rPr sz="3150" b="0" i="1" kern="0" spc="0">
+              <a:rPr sz="5000" b="0" i="1" kern="0" spc="0">
                 <a:solidFill>
                   <a:srgbClr val="FFFFFF"/>
                 </a:solidFill>
@@ -8017,7 +8017,7 @@
         <p:spPr>
           <a:xfrm>
             <a:off x="9134475" y="4572000"/>
-            <a:ext cx="19050" cy="2647950"/>
+            <a:ext cx="19050" cy="1457325"/>
           </a:xfrm>
           <a:prstGeom prst="rect">
             <a:avLst/>
@@ -8059,8 +8059,8 @@
         </p:nvSpPr>
         <p:spPr>
           <a:xfrm>
-            <a:off x="1905000" y="4762500"/>
-            <a:ext cx="8382000" cy="1905000"/>
+            <a:off x="4295775" y="4762500"/>
+            <a:ext cx="3600450" cy="1905000"/>
           </a:xfrm>
           <a:prstGeom prst="rect">
             <a:avLst/>
@@ -8094,23 +8094,23 @@
         </p:nvSpPr>
         <p:spPr>
           <a:xfrm>
-            <a:off x="1905000" y="6858000"/>
-            <a:ext cx="8382000" cy="1714500"/>
-          </a:xfrm>
-          <a:prstGeom prst="rect">
-            <a:avLst/>
-          </a:prstGeom>
-          <a:noFill/>
-        </p:spPr>
-        <p:txBody>
-          <a:bodyPr wrap="square" lIns="0" rIns="0" tIns="0" bIns="0">
-            <a:spAutoFit/>
-          </a:bodyPr>
-          <a:lstStyle/>
-          <a:p>
-            <a:pPr algn="ctr"/>
-            <a:r>
-              <a:rPr sz="1650" b="0" i="0" kern="0" spc="0">
+            <a:off x="4295775" y="6858000"/>
+            <a:ext cx="3600450" cy="1076325"/>
+          </a:xfrm>
+          <a:prstGeom prst="rect">
+            <a:avLst/>
+          </a:prstGeom>
+          <a:noFill/>
+        </p:spPr>
+        <p:txBody>
+          <a:bodyPr wrap="square" lIns="0" rIns="0" tIns="0" bIns="0">
+            <a:spAutoFit/>
+          </a:bodyPr>
+          <a:lstStyle/>
+          <a:p>
+            <a:pPr algn="ctr"/>
+            <a:r>
+              <a:rPr sz="1300" b="0" i="0" kern="0" spc="0">
                 <a:solidFill>
                   <a:srgbClr val="FFFFFF"/>
                 </a:solidFill>
@@ -8119,7 +8119,7 @@
               <a:t>del subsample femenino dice “Madre” como responsable de </a:t>
             </a:r>
             <a:r>
-              <a:rPr sz="1650" b="1" i="0" kern="0" spc="0">
+              <a:rPr sz="1300" b="1" i="0" kern="0" spc="0">
                 <a:solidFill>
                   <a:srgbClr val="FFFFFF"/>
                 </a:solidFill>
@@ -8128,7 +8128,7 @@
               <a:t>crianza</a:t>
             </a:r>
             <a:r>
-              <a:rPr sz="1650" b="0" i="0" kern="0" spc="0">
+              <a:rPr sz="1300" b="0" i="0" kern="0" spc="0">
                 <a:solidFill>
                   <a:srgbClr val="FFFFFF"/>
                 </a:solidFill>
@@ -8147,8 +8147,8 @@
         </p:nvSpPr>
         <p:spPr>
           <a:xfrm>
-            <a:off x="8001000" y="4762500"/>
-            <a:ext cx="8382000" cy="1905000"/>
+            <a:off x="10391775" y="4762500"/>
+            <a:ext cx="3600450" cy="1905000"/>
           </a:xfrm>
           <a:prstGeom prst="rect">
             <a:avLst/>
@@ -8182,23 +8182,23 @@
         </p:nvSpPr>
         <p:spPr>
           <a:xfrm>
-            <a:off x="8001000" y="6858000"/>
-            <a:ext cx="8382000" cy="1714500"/>
-          </a:xfrm>
-          <a:prstGeom prst="rect">
-            <a:avLst/>
-          </a:prstGeom>
-          <a:noFill/>
-        </p:spPr>
-        <p:txBody>
-          <a:bodyPr wrap="square" lIns="0" rIns="0" tIns="0" bIns="0">
-            <a:spAutoFit/>
-          </a:bodyPr>
-          <a:lstStyle/>
-          <a:p>
-            <a:pPr algn="ctr"/>
-            <a:r>
-              <a:rPr sz="1650" b="0" i="0" kern="0" spc="0">
+            <a:off x="10391775" y="6858000"/>
+            <a:ext cx="3600450" cy="1076325"/>
+          </a:xfrm>
+          <a:prstGeom prst="rect">
+            <a:avLst/>
+          </a:prstGeom>
+          <a:noFill/>
+        </p:spPr>
+        <p:txBody>
+          <a:bodyPr wrap="square" lIns="0" rIns="0" tIns="0" bIns="0">
+            <a:spAutoFit/>
+          </a:bodyPr>
+          <a:lstStyle/>
+          <a:p>
+            <a:pPr algn="ctr"/>
+            <a:r>
+              <a:rPr sz="1300" b="0" i="0" kern="0" spc="0">
                 <a:solidFill>
                   <a:srgbClr val="FFFFFF"/>
                 </a:solidFill>
@@ -8207,7 +8207,7 @@
               <a:t>declara “</a:t>
             </a:r>
             <a:r>
-              <a:rPr sz="1650" b="1" i="0" kern="0" spc="0">
+              <a:rPr sz="1300" b="1" i="0" kern="0" spc="0">
                 <a:solidFill>
                   <a:srgbClr val="FFFFFF"/>
                 </a:solidFill>
@@ -8216,7 +8216,7 @@
               <a:t>ambos por igual</a:t>
             </a:r>
             <a:r>
-              <a:rPr sz="1650" b="0" i="0" kern="0" spc="0">
+              <a:rPr sz="1300" b="0" i="0" kern="0" spc="0">
                 <a:solidFill>
                   <a:srgbClr val="FFFFFF"/>
                 </a:solidFill>
@@ -8471,7 +8471,7 @@
           <a:p>
             <a:pPr algn="ctr"/>
             <a:r>
-              <a:rPr sz="3150" b="0" i="0" kern="0" spc="0">
+              <a:rPr sz="5000" b="0" i="0" kern="0" spc="0">
                 <a:solidFill>
                   <a:srgbClr val="FFFFFF"/>
                 </a:solidFill>
@@ -8480,7 +8480,7 @@
               <a:t>LA MUJER DOMINICANA DICE QUE LA MADRE ES LA ÚNICA RESPONSABLE DE LA CRIANZA. EL HOMBRE DICE QUE SON AMBOS. </a:t>
             </a:r>
             <a:r>
-              <a:rPr sz="3150" b="0" i="1" kern="0" spc="0">
+              <a:rPr sz="5000" b="0" i="1" kern="0" spc="0">
                 <a:solidFill>
                   <a:srgbClr val="FFFFFF"/>
                 </a:solidFill>
@@ -8500,7 +8500,7 @@
         <p:spPr>
           <a:xfrm>
             <a:off x="9134475" y="4572000"/>
-            <a:ext cx="19050" cy="2647950"/>
+            <a:ext cx="19050" cy="1457325"/>
           </a:xfrm>
           <a:prstGeom prst="rect">
             <a:avLst/>
@@ -8542,8 +8542,8 @@
         </p:nvSpPr>
         <p:spPr>
           <a:xfrm>
-            <a:off x="1905000" y="4762500"/>
-            <a:ext cx="8382000" cy="1905000"/>
+            <a:off x="4295775" y="4762500"/>
+            <a:ext cx="3600450" cy="1905000"/>
           </a:xfrm>
           <a:prstGeom prst="rect">
             <a:avLst/>
@@ -8577,23 +8577,23 @@
         </p:nvSpPr>
         <p:spPr>
           <a:xfrm>
-            <a:off x="1905000" y="6858000"/>
-            <a:ext cx="8382000" cy="1714500"/>
-          </a:xfrm>
-          <a:prstGeom prst="rect">
-            <a:avLst/>
-          </a:prstGeom>
-          <a:noFill/>
-        </p:spPr>
-        <p:txBody>
-          <a:bodyPr wrap="square" lIns="0" rIns="0" tIns="0" bIns="0">
-            <a:spAutoFit/>
-          </a:bodyPr>
-          <a:lstStyle/>
-          <a:p>
-            <a:pPr algn="ctr"/>
-            <a:r>
-              <a:rPr sz="1650" b="0" i="0" kern="0" spc="0">
+            <a:off x="4295775" y="6858000"/>
+            <a:ext cx="3600450" cy="1076325"/>
+          </a:xfrm>
+          <a:prstGeom prst="rect">
+            <a:avLst/>
+          </a:prstGeom>
+          <a:noFill/>
+        </p:spPr>
+        <p:txBody>
+          <a:bodyPr wrap="square" lIns="0" rIns="0" tIns="0" bIns="0">
+            <a:spAutoFit/>
+          </a:bodyPr>
+          <a:lstStyle/>
+          <a:p>
+            <a:pPr algn="ctr"/>
+            <a:r>
+              <a:rPr sz="1300" b="0" i="0" kern="0" spc="0">
                 <a:solidFill>
                   <a:srgbClr val="FFFFFF"/>
                 </a:solidFill>
@@ -8602,7 +8602,7 @@
               <a:t>del subset femenino (n=305) declara “Madre” como quien tiene la </a:t>
             </a:r>
             <a:r>
-              <a:rPr sz="1650" b="1" i="0" kern="0" spc="0">
+              <a:rPr sz="1300" b="1" i="0" kern="0" spc="0">
                 <a:solidFill>
                   <a:srgbClr val="FFFFFF"/>
                 </a:solidFill>
@@ -8611,7 +8611,7 @@
               <a:t>mayor responsabilidad</a:t>
             </a:r>
             <a:r>
-              <a:rPr sz="1650" b="0" i="0" kern="0" spc="0">
+              <a:rPr sz="1300" b="0" i="0" kern="0" spc="0">
                 <a:solidFill>
                   <a:srgbClr val="FFFFFF"/>
                 </a:solidFill>
@@ -8630,8 +8630,8 @@
         </p:nvSpPr>
         <p:spPr>
           <a:xfrm>
-            <a:off x="8001000" y="4762500"/>
-            <a:ext cx="8382000" cy="1905000"/>
+            <a:off x="10391775" y="4762500"/>
+            <a:ext cx="3600450" cy="1905000"/>
           </a:xfrm>
           <a:prstGeom prst="rect">
             <a:avLst/>
@@ -8665,23 +8665,23 @@
         </p:nvSpPr>
         <p:spPr>
           <a:xfrm>
-            <a:off x="8001000" y="6858000"/>
-            <a:ext cx="8382000" cy="1714500"/>
-          </a:xfrm>
-          <a:prstGeom prst="rect">
-            <a:avLst/>
-          </a:prstGeom>
-          <a:noFill/>
-        </p:spPr>
-        <p:txBody>
-          <a:bodyPr wrap="square" lIns="0" rIns="0" tIns="0" bIns="0">
-            <a:spAutoFit/>
-          </a:bodyPr>
-          <a:lstStyle/>
-          <a:p>
-            <a:pPr algn="ctr"/>
-            <a:r>
-              <a:rPr sz="1650" b="0" i="0" kern="0" spc="0">
+            <a:off x="10391775" y="6858000"/>
+            <a:ext cx="3600450" cy="1076325"/>
+          </a:xfrm>
+          <a:prstGeom prst="rect">
+            <a:avLst/>
+          </a:prstGeom>
+          <a:noFill/>
+        </p:spPr>
+        <p:txBody>
+          <a:bodyPr wrap="square" lIns="0" rIns="0" tIns="0" bIns="0">
+            <a:spAutoFit/>
+          </a:bodyPr>
+          <a:lstStyle/>
+          <a:p>
+            <a:pPr algn="ctr"/>
+            <a:r>
+              <a:rPr sz="1300" b="0" i="0" kern="0" spc="0">
                 <a:solidFill>
                   <a:srgbClr val="FFFFFF"/>
                 </a:solidFill>
@@ -8690,7 +8690,7 @@
               <a:t>del subset masculino (n=195) declara “</a:t>
             </a:r>
             <a:r>
-              <a:rPr sz="1650" b="1" i="0" kern="0" spc="0">
+              <a:rPr sz="1300" b="1" i="0" kern="0" spc="0">
                 <a:solidFill>
                   <a:srgbClr val="FFFFFF"/>
                 </a:solidFill>
@@ -8699,7 +8699,7 @@
               <a:t>Ambos padres</a:t>
             </a:r>
             <a:r>
-              <a:rPr sz="1650" b="0" i="0" kern="0" spc="0">
+              <a:rPr sz="1300" b="0" i="0" kern="0" spc="0">
                 <a:solidFill>
                   <a:srgbClr val="FFFFFF"/>
                 </a:solidFill>
@@ -8954,7 +8954,7 @@
           <a:p>
             <a:pPr algn="ctr"/>
             <a:r>
-              <a:rPr sz="3150" b="0" i="0" kern="0" spc="0">
+              <a:rPr sz="5000" b="0" i="0" kern="0" spc="0">
                 <a:solidFill>
                   <a:srgbClr val="FFFFFF"/>
                 </a:solidFill>
@@ -8963,7 +8963,7 @@
               <a:t>59.4% DE LAS MUJERES DEL ESTRATO E SON LAS ÚNICAS RESPONSABLES DE LA CRIANZA, VS 43.5% EN AB. </a:t>
             </a:r>
             <a:r>
-              <a:rPr sz="3150" b="0" i="1" kern="0" spc="0">
+              <a:rPr sz="5000" b="0" i="1" kern="0" spc="0">
                 <a:solidFill>
                   <a:srgbClr val="FFFFFF"/>
                 </a:solidFill>
@@ -8983,7 +8983,7 @@
         <p:spPr>
           <a:xfrm>
             <a:off x="6848475" y="4572000"/>
-            <a:ext cx="19050" cy="2647950"/>
+            <a:ext cx="19050" cy="1457325"/>
           </a:xfrm>
           <a:prstGeom prst="rect">
             <a:avLst/>
@@ -9026,7 +9026,7 @@
         <p:spPr>
           <a:xfrm>
             <a:off x="11420475" y="4572000"/>
-            <a:ext cx="19050" cy="2647950"/>
+            <a:ext cx="19050" cy="1457325"/>
           </a:xfrm>
           <a:prstGeom prst="rect">
             <a:avLst/>
@@ -9068,8 +9068,8 @@
         </p:nvSpPr>
         <p:spPr>
           <a:xfrm>
-            <a:off x="1905000" y="4762500"/>
-            <a:ext cx="5334000" cy="1905000"/>
+            <a:off x="2771775" y="4762500"/>
+            <a:ext cx="3600450" cy="1905000"/>
           </a:xfrm>
           <a:prstGeom prst="rect">
             <a:avLst/>
@@ -9103,23 +9103,23 @@
         </p:nvSpPr>
         <p:spPr>
           <a:xfrm>
-            <a:off x="1905000" y="6858000"/>
-            <a:ext cx="5334000" cy="1714500"/>
-          </a:xfrm>
-          <a:prstGeom prst="rect">
-            <a:avLst/>
-          </a:prstGeom>
-          <a:noFill/>
-        </p:spPr>
-        <p:txBody>
-          <a:bodyPr wrap="square" lIns="0" rIns="0" tIns="0" bIns="0">
-            <a:spAutoFit/>
-          </a:bodyPr>
-          <a:lstStyle/>
-          <a:p>
-            <a:pPr algn="ctr"/>
-            <a:r>
-              <a:rPr sz="1650" b="0" i="0" kern="0" spc="0">
+            <a:off x="2771775" y="6858000"/>
+            <a:ext cx="3600450" cy="1076325"/>
+          </a:xfrm>
+          <a:prstGeom prst="rect">
+            <a:avLst/>
+          </a:prstGeom>
+          <a:noFill/>
+        </p:spPr>
+        <p:txBody>
+          <a:bodyPr wrap="square" lIns="0" rIns="0" tIns="0" bIns="0">
+            <a:spAutoFit/>
+          </a:bodyPr>
+          <a:lstStyle/>
+          <a:p>
+            <a:pPr algn="ctr"/>
+            <a:r>
+              <a:rPr sz="1300" b="0" i="0" kern="0" spc="0">
                 <a:solidFill>
                   <a:srgbClr val="FFFFFF"/>
                 </a:solidFill>
@@ -9128,7 +9128,7 @@
               <a:t>del subset </a:t>
             </a:r>
             <a:r>
-              <a:rPr sz="1650" b="1" i="0" kern="0" spc="0">
+              <a:rPr sz="1300" b="1" i="0" kern="0" spc="0">
                 <a:solidFill>
                   <a:srgbClr val="FFFFFF"/>
                 </a:solidFill>
@@ -9137,7 +9137,7 @@
               <a:t>NSE E</a:t>
             </a:r>
             <a:r>
-              <a:rPr sz="1650" b="0" i="0" kern="0" spc="0">
+              <a:rPr sz="1300" b="0" i="0" kern="0" spc="0">
                 <a:solidFill>
                   <a:srgbClr val="FFFFFF"/>
                 </a:solidFill>
@@ -9156,8 +9156,8 @@
         </p:nvSpPr>
         <p:spPr>
           <a:xfrm>
-            <a:off x="6477000" y="4762500"/>
-            <a:ext cx="5334000" cy="1905000"/>
+            <a:off x="7343775" y="4762500"/>
+            <a:ext cx="3600450" cy="1905000"/>
           </a:xfrm>
           <a:prstGeom prst="rect">
             <a:avLst/>
@@ -9191,23 +9191,23 @@
         </p:nvSpPr>
         <p:spPr>
           <a:xfrm>
-            <a:off x="6477000" y="6858000"/>
-            <a:ext cx="5334000" cy="1714500"/>
-          </a:xfrm>
-          <a:prstGeom prst="rect">
-            <a:avLst/>
-          </a:prstGeom>
-          <a:noFill/>
-        </p:spPr>
-        <p:txBody>
-          <a:bodyPr wrap="square" lIns="0" rIns="0" tIns="0" bIns="0">
-            <a:spAutoFit/>
-          </a:bodyPr>
-          <a:lstStyle/>
-          <a:p>
-            <a:pPr algn="ctr"/>
-            <a:r>
-              <a:rPr sz="1650" b="0" i="0" kern="0" spc="0">
+            <a:off x="7343775" y="6858000"/>
+            <a:ext cx="3600450" cy="1076325"/>
+          </a:xfrm>
+          <a:prstGeom prst="rect">
+            <a:avLst/>
+          </a:prstGeom>
+          <a:noFill/>
+        </p:spPr>
+        <p:txBody>
+          <a:bodyPr wrap="square" lIns="0" rIns="0" tIns="0" bIns="0">
+            <a:spAutoFit/>
+          </a:bodyPr>
+          <a:lstStyle/>
+          <a:p>
+            <a:pPr algn="ctr"/>
+            <a:r>
+              <a:rPr sz="1300" b="0" i="0" kern="0" spc="0">
                 <a:solidFill>
                   <a:srgbClr val="FFFFFF"/>
                 </a:solidFill>
@@ -9216,7 +9216,7 @@
               <a:t>del subset </a:t>
             </a:r>
             <a:r>
-              <a:rPr sz="1650" b="1" i="0" kern="0" spc="0">
+              <a:rPr sz="1300" b="1" i="0" kern="0" spc="0">
                 <a:solidFill>
                   <a:srgbClr val="FFFFFF"/>
                 </a:solidFill>
@@ -9225,7 +9225,7 @@
               <a:t>NSE D</a:t>
             </a:r>
             <a:r>
-              <a:rPr sz="1650" b="0" i="0" kern="0" spc="0">
+              <a:rPr sz="1300" b="0" i="0" kern="0" spc="0">
                 <a:solidFill>
                   <a:srgbClr val="FFFFFF"/>
                 </a:solidFill>
@@ -9244,8 +9244,8 @@
         </p:nvSpPr>
         <p:spPr>
           <a:xfrm>
-            <a:off x="11049000" y="4762500"/>
-            <a:ext cx="5334000" cy="1905000"/>
+            <a:off x="11915775" y="4762500"/>
+            <a:ext cx="3600450" cy="1905000"/>
           </a:xfrm>
           <a:prstGeom prst="rect">
             <a:avLst/>
@@ -9279,23 +9279,23 @@
         </p:nvSpPr>
         <p:spPr>
           <a:xfrm>
-            <a:off x="11049000" y="6858000"/>
-            <a:ext cx="5334000" cy="1714500"/>
-          </a:xfrm>
-          <a:prstGeom prst="rect">
-            <a:avLst/>
-          </a:prstGeom>
-          <a:noFill/>
-        </p:spPr>
-        <p:txBody>
-          <a:bodyPr wrap="square" lIns="0" rIns="0" tIns="0" bIns="0">
-            <a:spAutoFit/>
-          </a:bodyPr>
-          <a:lstStyle/>
-          <a:p>
-            <a:pPr algn="ctr"/>
-            <a:r>
-              <a:rPr sz="1650" b="0" i="0" kern="0" spc="0">
+            <a:off x="11915775" y="6858000"/>
+            <a:ext cx="3600450" cy="1076325"/>
+          </a:xfrm>
+          <a:prstGeom prst="rect">
+            <a:avLst/>
+          </a:prstGeom>
+          <a:noFill/>
+        </p:spPr>
+        <p:txBody>
+          <a:bodyPr wrap="square" lIns="0" rIns="0" tIns="0" bIns="0">
+            <a:spAutoFit/>
+          </a:bodyPr>
+          <a:lstStyle/>
+          <a:p>
+            <a:pPr algn="ctr"/>
+            <a:r>
+              <a:rPr sz="1300" b="0" i="0" kern="0" spc="0">
                 <a:solidFill>
                   <a:srgbClr val="FFFFFF"/>
                 </a:solidFill>
@@ -9304,7 +9304,7 @@
               <a:t>del subset </a:t>
             </a:r>
             <a:r>
-              <a:rPr sz="1650" b="1" i="0" kern="0" spc="0">
+              <a:rPr sz="1300" b="1" i="0" kern="0" spc="0">
                 <a:solidFill>
                   <a:srgbClr val="FFFFFF"/>
                 </a:solidFill>
@@ -9313,7 +9313,7 @@
               <a:t>NSE C</a:t>
             </a:r>
             <a:r>
-              <a:rPr sz="1650" b="0" i="0" kern="0" spc="0">
+              <a:rPr sz="1300" b="0" i="0" kern="0" spc="0">
                 <a:solidFill>
                   <a:srgbClr val="FFFFFF"/>
                 </a:solidFill>
@@ -9568,7 +9568,7 @@
           <a:p>
             <a:pPr algn="ctr"/>
             <a:r>
-              <a:rPr sz="3150" b="0" i="0" kern="0" spc="0">
+              <a:rPr sz="5000" b="0" i="0" kern="0" spc="0">
                 <a:solidFill>
                   <a:srgbClr val="FFFFFF"/>
                 </a:solidFill>
@@ -9577,7 +9577,7 @@
               <a:t>85.4% DE LAS MUJERES DEL ESTUDIO YA TIENE HIJOS. DE LAS QUE NO, </a:t>
             </a:r>
             <a:r>
-              <a:rPr sz="3150" b="0" i="1" kern="0" spc="0">
+              <a:rPr sz="5000" b="0" i="1" kern="0" spc="0">
                 <a:solidFill>
                   <a:srgbClr val="FFFFFF"/>
                 </a:solidFill>
@@ -9597,7 +9597,7 @@
         <p:spPr>
           <a:xfrm>
             <a:off x="9134475" y="4572000"/>
-            <a:ext cx="19050" cy="2647950"/>
+            <a:ext cx="19050" cy="1457325"/>
           </a:xfrm>
           <a:prstGeom prst="rect">
             <a:avLst/>
@@ -9639,8 +9639,8 @@
         </p:nvSpPr>
         <p:spPr>
           <a:xfrm>
-            <a:off x="1905000" y="4762500"/>
-            <a:ext cx="8382000" cy="1905000"/>
+            <a:off x="4295775" y="4762500"/>
+            <a:ext cx="3600450" cy="1905000"/>
           </a:xfrm>
           <a:prstGeom prst="rect">
             <a:avLst/>
@@ -9674,23 +9674,23 @@
         </p:nvSpPr>
         <p:spPr>
           <a:xfrm>
-            <a:off x="1905000" y="6858000"/>
-            <a:ext cx="8382000" cy="1714500"/>
-          </a:xfrm>
-          <a:prstGeom prst="rect">
-            <a:avLst/>
-          </a:prstGeom>
-          <a:noFill/>
-        </p:spPr>
-        <p:txBody>
-          <a:bodyPr wrap="square" lIns="0" rIns="0" tIns="0" bIns="0">
-            <a:spAutoFit/>
-          </a:bodyPr>
-          <a:lstStyle/>
-          <a:p>
-            <a:pPr algn="ctr"/>
-            <a:r>
-              <a:rPr sz="1650" b="0" i="0" kern="0" spc="0">
+            <a:off x="4295775" y="6858000"/>
+            <a:ext cx="3600450" cy="1076325"/>
+          </a:xfrm>
+          <a:prstGeom prst="rect">
+            <a:avLst/>
+          </a:prstGeom>
+          <a:noFill/>
+        </p:spPr>
+        <p:txBody>
+          <a:bodyPr wrap="square" lIns="0" rIns="0" tIns="0" bIns="0">
+            <a:spAutoFit/>
+          </a:bodyPr>
+          <a:lstStyle/>
+          <a:p>
+            <a:pPr algn="ctr"/>
+            <a:r>
+              <a:rPr sz="1300" b="0" i="0" kern="0" spc="0">
                 <a:solidFill>
                   <a:srgbClr val="FFFFFF"/>
                 </a:solidFill>
@@ -9699,7 +9699,7 @@
               <a:t>del subsample femenino (n=305) declara “</a:t>
             </a:r>
             <a:r>
-              <a:rPr sz="1650" b="1" i="0" kern="0" spc="0">
+              <a:rPr sz="1300" b="1" i="0" kern="0" spc="0">
                 <a:solidFill>
                   <a:srgbClr val="FFFFFF"/>
                 </a:solidFill>
@@ -9708,7 +9708,7 @@
               <a:t>Tengo hijos actualmente</a:t>
             </a:r>
             <a:r>
-              <a:rPr sz="1650" b="0" i="0" kern="0" spc="0">
+              <a:rPr sz="1300" b="0" i="0" kern="0" spc="0">
                 <a:solidFill>
                   <a:srgbClr val="FFFFFF"/>
                 </a:solidFill>
@@ -9727,8 +9727,8 @@
         </p:nvSpPr>
         <p:spPr>
           <a:xfrm>
-            <a:off x="8001000" y="4762500"/>
-            <a:ext cx="8382000" cy="1905000"/>
+            <a:off x="10391775" y="4762500"/>
+            <a:ext cx="3600450" cy="1905000"/>
           </a:xfrm>
           <a:prstGeom prst="rect">
             <a:avLst/>
@@ -9762,23 +9762,23 @@
         </p:nvSpPr>
         <p:spPr>
           <a:xfrm>
-            <a:off x="8001000" y="6858000"/>
-            <a:ext cx="8382000" cy="1714500"/>
-          </a:xfrm>
-          <a:prstGeom prst="rect">
-            <a:avLst/>
-          </a:prstGeom>
-          <a:noFill/>
-        </p:spPr>
-        <p:txBody>
-          <a:bodyPr wrap="square" lIns="0" rIns="0" tIns="0" bIns="0">
-            <a:spAutoFit/>
-          </a:bodyPr>
-          <a:lstStyle/>
-          <a:p>
-            <a:pPr algn="ctr"/>
-            <a:r>
-              <a:rPr sz="1650" b="0" i="0" kern="0" spc="0">
+            <a:off x="10391775" y="6858000"/>
+            <a:ext cx="3600450" cy="1076325"/>
+          </a:xfrm>
+          <a:prstGeom prst="rect">
+            <a:avLst/>
+          </a:prstGeom>
+          <a:noFill/>
+        </p:spPr>
+        <p:txBody>
+          <a:bodyPr wrap="square" lIns="0" rIns="0" tIns="0" bIns="0">
+            <a:spAutoFit/>
+          </a:bodyPr>
+          <a:lstStyle/>
+          <a:p>
+            <a:pPr algn="ctr"/>
+            <a:r>
+              <a:rPr sz="1300" b="0" i="0" kern="0" spc="0">
                 <a:solidFill>
                   <a:srgbClr val="FFFFFF"/>
                 </a:solidFill>
@@ -9787,7 +9787,7 @@
               <a:t>del total femenino no tiene hijos. Razones declaradas: “</a:t>
             </a:r>
             <a:r>
-              <a:rPr sz="1650" b="1" i="0" kern="0" spc="0">
+              <a:rPr sz="1300" b="1" i="0" kern="0" spc="0">
                 <a:solidFill>
                   <a:srgbClr val="FFFFFF"/>
                 </a:solidFill>
@@ -9796,7 +9796,7 @@
               <a:t>no es prioridad</a:t>
             </a:r>
             <a:r>
-              <a:rPr sz="1650" b="0" i="0" kern="0" spc="0">
+              <a:rPr sz="1300" b="0" i="0" kern="0" spc="0">
                 <a:solidFill>
                   <a:srgbClr val="FFFFFF"/>
                 </a:solidFill>
@@ -10051,7 +10051,7 @@
           <a:p>
             <a:pPr algn="ctr"/>
             <a:r>
-              <a:rPr sz="3150" b="0" i="0" kern="0" spc="0">
+              <a:rPr sz="5000" b="0" i="0" kern="0" spc="0">
                 <a:solidFill>
                   <a:srgbClr val="FFFFFF"/>
                 </a:solidFill>
@@ -10060,7 +10060,7 @@
               <a:t>66.6% DE LAS MUJERES DICE QUE COCINAR LO HACE ELLA. LAVAR LA ROPA: 63.0%. LIMPIAR LA CASA: 59.6%. </a:t>
             </a:r>
             <a:r>
-              <a:rPr sz="3150" b="0" i="1" kern="0" spc="0">
+              <a:rPr sz="5000" b="0" i="1" kern="0" spc="0">
                 <a:solidFill>
                   <a:srgbClr val="FFFFFF"/>
                 </a:solidFill>
@@ -10080,7 +10080,7 @@
         <p:spPr>
           <a:xfrm>
             <a:off x="9134475" y="4572000"/>
-            <a:ext cx="19050" cy="2647950"/>
+            <a:ext cx="19050" cy="1457325"/>
           </a:xfrm>
           <a:prstGeom prst="rect">
             <a:avLst/>
@@ -10122,8 +10122,8 @@
         </p:nvSpPr>
         <p:spPr>
           <a:xfrm>
-            <a:off x="1905000" y="4762500"/>
-            <a:ext cx="8382000" cy="1905000"/>
+            <a:off x="4295775" y="4762500"/>
+            <a:ext cx="3600450" cy="1905000"/>
           </a:xfrm>
           <a:prstGeom prst="rect">
             <a:avLst/>
@@ -10157,23 +10157,23 @@
         </p:nvSpPr>
         <p:spPr>
           <a:xfrm>
-            <a:off x="1905000" y="6858000"/>
-            <a:ext cx="8382000" cy="1714500"/>
-          </a:xfrm>
-          <a:prstGeom prst="rect">
-            <a:avLst/>
-          </a:prstGeom>
-          <a:noFill/>
-        </p:spPr>
-        <p:txBody>
-          <a:bodyPr wrap="square" lIns="0" rIns="0" tIns="0" bIns="0">
-            <a:spAutoFit/>
-          </a:bodyPr>
-          <a:lstStyle/>
-          <a:p>
-            <a:pPr algn="ctr"/>
-            <a:r>
-              <a:rPr sz="1650" b="0" i="0" kern="0" spc="0">
+            <a:off x="4295775" y="6858000"/>
+            <a:ext cx="3600450" cy="1076325"/>
+          </a:xfrm>
+          <a:prstGeom prst="rect">
+            <a:avLst/>
+          </a:prstGeom>
+          <a:noFill/>
+        </p:spPr>
+        <p:txBody>
+          <a:bodyPr wrap="square" lIns="0" rIns="0" tIns="0" bIns="0">
+            <a:spAutoFit/>
+          </a:bodyPr>
+          <a:lstStyle/>
+          <a:p>
+            <a:pPr algn="ctr"/>
+            <a:r>
+              <a:rPr sz="1300" b="0" i="0" kern="0" spc="0">
                 <a:solidFill>
                   <a:srgbClr val="FFFFFF"/>
                 </a:solidFill>
@@ -10182,7 +10182,7 @@
               <a:t>del subsample femenino (n=305) dice que </a:t>
             </a:r>
             <a:r>
-              <a:rPr sz="1650" b="1" i="0" kern="0" spc="0">
+              <a:rPr sz="1300" b="1" i="0" kern="0" spc="0">
                 <a:solidFill>
                   <a:srgbClr val="FFFFFF"/>
                 </a:solidFill>
@@ -10191,7 +10191,7 @@
               <a:t>cocinar</a:t>
             </a:r>
             <a:r>
-              <a:rPr sz="1650" b="0" i="0" kern="0" spc="0">
+              <a:rPr sz="1300" b="0" i="0" kern="0" spc="0">
                 <a:solidFill>
                   <a:srgbClr val="FFFFFF"/>
                 </a:solidFill>
@@ -10210,8 +10210,8 @@
         </p:nvSpPr>
         <p:spPr>
           <a:xfrm>
-            <a:off x="8001000" y="4762500"/>
-            <a:ext cx="8382000" cy="1905000"/>
+            <a:off x="10391775" y="4762500"/>
+            <a:ext cx="3600450" cy="1905000"/>
           </a:xfrm>
           <a:prstGeom prst="rect">
             <a:avLst/>
@@ -10245,23 +10245,23 @@
         </p:nvSpPr>
         <p:spPr>
           <a:xfrm>
-            <a:off x="8001000" y="6858000"/>
-            <a:ext cx="8382000" cy="1714500"/>
-          </a:xfrm>
-          <a:prstGeom prst="rect">
-            <a:avLst/>
-          </a:prstGeom>
-          <a:noFill/>
-        </p:spPr>
-        <p:txBody>
-          <a:bodyPr wrap="square" lIns="0" rIns="0" tIns="0" bIns="0">
-            <a:spAutoFit/>
-          </a:bodyPr>
-          <a:lstStyle/>
-          <a:p>
-            <a:pPr algn="ctr"/>
-            <a:r>
-              <a:rPr sz="1650" b="0" i="0" kern="0" spc="0">
+            <a:off x="10391775" y="6858000"/>
+            <a:ext cx="3600450" cy="1076325"/>
+          </a:xfrm>
+          <a:prstGeom prst="rect">
+            <a:avLst/>
+          </a:prstGeom>
+          <a:noFill/>
+        </p:spPr>
+        <p:txBody>
+          <a:bodyPr wrap="square" lIns="0" rIns="0" tIns="0" bIns="0">
+            <a:spAutoFit/>
+          </a:bodyPr>
+          <a:lstStyle/>
+          <a:p>
+            <a:pPr algn="ctr"/>
+            <a:r>
+              <a:rPr sz="1300" b="0" i="0" kern="0" spc="0">
                 <a:solidFill>
                   <a:srgbClr val="FFFFFF"/>
                 </a:solidFill>
@@ -10270,7 +10270,7 @@
               <a:t>dice que </a:t>
             </a:r>
             <a:r>
-              <a:rPr sz="1650" b="1" i="0" kern="0" spc="0">
+              <a:rPr sz="1300" b="1" i="0" kern="0" spc="0">
                 <a:solidFill>
                   <a:srgbClr val="FFFFFF"/>
                 </a:solidFill>
@@ -10279,7 +10279,7 @@
               <a:t>lavar la ropa</a:t>
             </a:r>
             <a:r>
-              <a:rPr sz="1650" b="0" i="0" kern="0" spc="0">
+              <a:rPr sz="1300" b="0" i="0" kern="0" spc="0">
                 <a:solidFill>
                   <a:srgbClr val="FFFFFF"/>
                 </a:solidFill>

</xml_diff>